<commit_message>
Save EAAI SOH benchmark paper and current analyses
</commit_message>
<xml_diff>
--- a/LATEX/EAAI_2/figures/source/baseline_model_comparison.pptx
+++ b/LATEX/EAAI_2/figures/source/baseline_model_comparison.pptx
@@ -129,7 +129,7 @@
           <p:cNvPr id="2" name="Titel 1">
             <a:extLst>
               <a:ext uri="{FF2B5EF4-FFF2-40B4-BE49-F238E27FC236}">
-                <a16:creationId xmlns:a16="http://schemas.microsoft.com/office/drawing/2014/main" id="{D02913A9-77A0-D778-02A2-71C288105180}"/>
+                <a16:creationId xmlns:a16="http://schemas.microsoft.com/office/drawing/2014/main" id="{8248DCBC-A14A-4AF7-9D27-A07DB97CBA74}"/>
               </a:ext>
             </a:extLst>
           </p:cNvPr>
@@ -166,7 +166,7 @@
           <p:cNvPr id="3" name="Untertitel 2">
             <a:extLst>
               <a:ext uri="{FF2B5EF4-FFF2-40B4-BE49-F238E27FC236}">
-                <a16:creationId xmlns:a16="http://schemas.microsoft.com/office/drawing/2014/main" id="{B3E459B6-2C88-E98F-2B90-3B9149618831}"/>
+                <a16:creationId xmlns:a16="http://schemas.microsoft.com/office/drawing/2014/main" id="{FDD1546A-4367-4947-9462-6534A32A1E76}"/>
               </a:ext>
             </a:extLst>
           </p:cNvPr>
@@ -236,7 +236,7 @@
           <p:cNvPr id="4" name="Datumsplatzhalter 3">
             <a:extLst>
               <a:ext uri="{FF2B5EF4-FFF2-40B4-BE49-F238E27FC236}">
-                <a16:creationId xmlns:a16="http://schemas.microsoft.com/office/drawing/2014/main" id="{4B986C0F-1622-D29B-1CA1-66D8B00BD0B3}"/>
+                <a16:creationId xmlns:a16="http://schemas.microsoft.com/office/drawing/2014/main" id="{6C42BF5C-EA8A-41F1-A179-0B0ECD5B229E}"/>
               </a:ext>
             </a:extLst>
           </p:cNvPr>
@@ -252,9 +252,9 @@
           <a:bodyPr/>
           <a:lstStyle/>
           <a:p>
-            <a:fld id="{D103C16D-CC5B-4681-8DC2-91DF2744339A}" type="datetimeFigureOut">
+            <a:fld id="{8DFE14BD-22BE-4CAC-BACA-BD69077A56DA}" type="datetimeFigureOut">
               <a:rPr lang="de-DE" smtClean="0"/>
-              <a:t>17.08.2026</a:t>
+              <a:t>04.09.2026</a:t>
             </a:fld>
             <a:endParaRPr lang="de-DE"/>
           </a:p>
@@ -265,7 +265,7 @@
           <p:cNvPr id="5" name="Fußzeilenplatzhalter 4">
             <a:extLst>
               <a:ext uri="{FF2B5EF4-FFF2-40B4-BE49-F238E27FC236}">
-                <a16:creationId xmlns:a16="http://schemas.microsoft.com/office/drawing/2014/main" id="{35C7689B-8A25-302F-2659-7DC341D3AFB8}"/>
+                <a16:creationId xmlns:a16="http://schemas.microsoft.com/office/drawing/2014/main" id="{D63E96E5-09BF-4D21-8F2B-E03E801204FA}"/>
               </a:ext>
             </a:extLst>
           </p:cNvPr>
@@ -290,7 +290,7 @@
           <p:cNvPr id="6" name="Foliennummernplatzhalter 5">
             <a:extLst>
               <a:ext uri="{FF2B5EF4-FFF2-40B4-BE49-F238E27FC236}">
-                <a16:creationId xmlns:a16="http://schemas.microsoft.com/office/drawing/2014/main" id="{ACCB6C4B-86DF-6F52-2A35-8A9CE2875F5B}"/>
+                <a16:creationId xmlns:a16="http://schemas.microsoft.com/office/drawing/2014/main" id="{629DE67A-969A-4320-B53B-6AAA728F4D78}"/>
               </a:ext>
             </a:extLst>
           </p:cNvPr>
@@ -306,7 +306,7 @@
           <a:bodyPr/>
           <a:lstStyle/>
           <a:p>
-            <a:fld id="{CCEF56B2-4225-4500-AB80-2ED1D5A5CA1B}" type="slidenum">
+            <a:fld id="{73257CB3-FA39-4251-BF0A-FFECE0B778D5}" type="slidenum">
               <a:rPr lang="de-DE" smtClean="0"/>
               <a:t>‹Nr.›</a:t>
             </a:fld>
@@ -317,7 +317,7 @@
     </p:spTree>
     <p:extLst>
       <p:ext uri="{BB962C8B-B14F-4D97-AF65-F5344CB8AC3E}">
-        <p14:creationId xmlns:p14="http://schemas.microsoft.com/office/powerpoint/2010/main" val="526852625"/>
+        <p14:creationId xmlns:p14="http://schemas.microsoft.com/office/powerpoint/2010/main" val="1374401997"/>
       </p:ext>
     </p:extLst>
   </p:cSld>
@@ -349,7 +349,7 @@
           <p:cNvPr id="2" name="Titel 1">
             <a:extLst>
               <a:ext uri="{FF2B5EF4-FFF2-40B4-BE49-F238E27FC236}">
-                <a16:creationId xmlns:a16="http://schemas.microsoft.com/office/drawing/2014/main" id="{B700D8DF-99D7-F54C-AAD5-773D68C28CA4}"/>
+                <a16:creationId xmlns:a16="http://schemas.microsoft.com/office/drawing/2014/main" id="{C9B9A465-0C14-4BA6-AADF-57D8595E204A}"/>
               </a:ext>
             </a:extLst>
           </p:cNvPr>
@@ -377,7 +377,7 @@
           <p:cNvPr id="3" name="Vertikaler Textplatzhalter 2">
             <a:extLst>
               <a:ext uri="{FF2B5EF4-FFF2-40B4-BE49-F238E27FC236}">
-                <a16:creationId xmlns:a16="http://schemas.microsoft.com/office/drawing/2014/main" id="{DEB3F2E8-E305-A0DA-DDB8-007CF3C0C3DE}"/>
+                <a16:creationId xmlns:a16="http://schemas.microsoft.com/office/drawing/2014/main" id="{5EC9A0F5-9052-43E0-8E72-257989C60362}"/>
               </a:ext>
             </a:extLst>
           </p:cNvPr>
@@ -434,7 +434,7 @@
           <p:cNvPr id="4" name="Datumsplatzhalter 3">
             <a:extLst>
               <a:ext uri="{FF2B5EF4-FFF2-40B4-BE49-F238E27FC236}">
-                <a16:creationId xmlns:a16="http://schemas.microsoft.com/office/drawing/2014/main" id="{9B2AAB2B-96FF-7D97-975E-515E2CB03C10}"/>
+                <a16:creationId xmlns:a16="http://schemas.microsoft.com/office/drawing/2014/main" id="{33160E7E-C253-4E78-B930-21D20FAA406F}"/>
               </a:ext>
             </a:extLst>
           </p:cNvPr>
@@ -450,9 +450,9 @@
           <a:bodyPr/>
           <a:lstStyle/>
           <a:p>
-            <a:fld id="{D103C16D-CC5B-4681-8DC2-91DF2744339A}" type="datetimeFigureOut">
+            <a:fld id="{8DFE14BD-22BE-4CAC-BACA-BD69077A56DA}" type="datetimeFigureOut">
               <a:rPr lang="de-DE" smtClean="0"/>
-              <a:t>17.08.2026</a:t>
+              <a:t>04.09.2026</a:t>
             </a:fld>
             <a:endParaRPr lang="de-DE"/>
           </a:p>
@@ -463,7 +463,7 @@
           <p:cNvPr id="5" name="Fußzeilenplatzhalter 4">
             <a:extLst>
               <a:ext uri="{FF2B5EF4-FFF2-40B4-BE49-F238E27FC236}">
-                <a16:creationId xmlns:a16="http://schemas.microsoft.com/office/drawing/2014/main" id="{FB9D8826-AE59-8000-E44A-B5834CD687CE}"/>
+                <a16:creationId xmlns:a16="http://schemas.microsoft.com/office/drawing/2014/main" id="{1C61A43E-1DAE-4919-936A-25F01E7515F6}"/>
               </a:ext>
             </a:extLst>
           </p:cNvPr>
@@ -488,7 +488,7 @@
           <p:cNvPr id="6" name="Foliennummernplatzhalter 5">
             <a:extLst>
               <a:ext uri="{FF2B5EF4-FFF2-40B4-BE49-F238E27FC236}">
-                <a16:creationId xmlns:a16="http://schemas.microsoft.com/office/drawing/2014/main" id="{4D30E52B-7654-A2CB-7671-B0917F1AECD3}"/>
+                <a16:creationId xmlns:a16="http://schemas.microsoft.com/office/drawing/2014/main" id="{590F7A0E-7C27-4850-8740-76B1A7ED6E9A}"/>
               </a:ext>
             </a:extLst>
           </p:cNvPr>
@@ -504,7 +504,7 @@
           <a:bodyPr/>
           <a:lstStyle/>
           <a:p>
-            <a:fld id="{CCEF56B2-4225-4500-AB80-2ED1D5A5CA1B}" type="slidenum">
+            <a:fld id="{73257CB3-FA39-4251-BF0A-FFECE0B778D5}" type="slidenum">
               <a:rPr lang="de-DE" smtClean="0"/>
               <a:t>‹Nr.›</a:t>
             </a:fld>
@@ -515,7 +515,7 @@
     </p:spTree>
     <p:extLst>
       <p:ext uri="{BB962C8B-B14F-4D97-AF65-F5344CB8AC3E}">
-        <p14:creationId xmlns:p14="http://schemas.microsoft.com/office/powerpoint/2010/main" val="2029680165"/>
+        <p14:creationId xmlns:p14="http://schemas.microsoft.com/office/powerpoint/2010/main" val="3631050083"/>
       </p:ext>
     </p:extLst>
   </p:cSld>
@@ -547,7 +547,7 @@
           <p:cNvPr id="2" name="Vertikaler Titel 1">
             <a:extLst>
               <a:ext uri="{FF2B5EF4-FFF2-40B4-BE49-F238E27FC236}">
-                <a16:creationId xmlns:a16="http://schemas.microsoft.com/office/drawing/2014/main" id="{277FE87B-91A7-BA70-67A0-D5962A75BA8C}"/>
+                <a16:creationId xmlns:a16="http://schemas.microsoft.com/office/drawing/2014/main" id="{F502AC80-4385-4B9C-AD23-D91CF243FAC5}"/>
               </a:ext>
             </a:extLst>
           </p:cNvPr>
@@ -580,7 +580,7 @@
           <p:cNvPr id="3" name="Vertikaler Textplatzhalter 2">
             <a:extLst>
               <a:ext uri="{FF2B5EF4-FFF2-40B4-BE49-F238E27FC236}">
-                <a16:creationId xmlns:a16="http://schemas.microsoft.com/office/drawing/2014/main" id="{7FD5A955-CA8E-9DCE-7490-20252E766FD4}"/>
+                <a16:creationId xmlns:a16="http://schemas.microsoft.com/office/drawing/2014/main" id="{9EC29FA3-C355-47CE-AA5C-8B8D638C5536}"/>
               </a:ext>
             </a:extLst>
           </p:cNvPr>
@@ -642,7 +642,7 @@
           <p:cNvPr id="4" name="Datumsplatzhalter 3">
             <a:extLst>
               <a:ext uri="{FF2B5EF4-FFF2-40B4-BE49-F238E27FC236}">
-                <a16:creationId xmlns:a16="http://schemas.microsoft.com/office/drawing/2014/main" id="{1094E934-8EFC-F85D-5C9C-FB7F1CF0DB0F}"/>
+                <a16:creationId xmlns:a16="http://schemas.microsoft.com/office/drawing/2014/main" id="{C353AD63-1C27-4256-BEAA-710A38BA8491}"/>
               </a:ext>
             </a:extLst>
           </p:cNvPr>
@@ -658,9 +658,9 @@
           <a:bodyPr/>
           <a:lstStyle/>
           <a:p>
-            <a:fld id="{D103C16D-CC5B-4681-8DC2-91DF2744339A}" type="datetimeFigureOut">
+            <a:fld id="{8DFE14BD-22BE-4CAC-BACA-BD69077A56DA}" type="datetimeFigureOut">
               <a:rPr lang="de-DE" smtClean="0"/>
-              <a:t>17.08.2026</a:t>
+              <a:t>04.09.2026</a:t>
             </a:fld>
             <a:endParaRPr lang="de-DE"/>
           </a:p>
@@ -671,7 +671,7 @@
           <p:cNvPr id="5" name="Fußzeilenplatzhalter 4">
             <a:extLst>
               <a:ext uri="{FF2B5EF4-FFF2-40B4-BE49-F238E27FC236}">
-                <a16:creationId xmlns:a16="http://schemas.microsoft.com/office/drawing/2014/main" id="{C58FA61F-1BA4-688F-7CFF-B3CC11FA5F9C}"/>
+                <a16:creationId xmlns:a16="http://schemas.microsoft.com/office/drawing/2014/main" id="{86DABD50-DB46-4B69-A8C0-38503F74A999}"/>
               </a:ext>
             </a:extLst>
           </p:cNvPr>
@@ -696,7 +696,7 @@
           <p:cNvPr id="6" name="Foliennummernplatzhalter 5">
             <a:extLst>
               <a:ext uri="{FF2B5EF4-FFF2-40B4-BE49-F238E27FC236}">
-                <a16:creationId xmlns:a16="http://schemas.microsoft.com/office/drawing/2014/main" id="{A88BD6CE-F062-E84B-77C2-84800DEC3CED}"/>
+                <a16:creationId xmlns:a16="http://schemas.microsoft.com/office/drawing/2014/main" id="{47E3DB8E-F2D2-4E82-8351-0894F6C3D882}"/>
               </a:ext>
             </a:extLst>
           </p:cNvPr>
@@ -712,7 +712,7 @@
           <a:bodyPr/>
           <a:lstStyle/>
           <a:p>
-            <a:fld id="{CCEF56B2-4225-4500-AB80-2ED1D5A5CA1B}" type="slidenum">
+            <a:fld id="{73257CB3-FA39-4251-BF0A-FFECE0B778D5}" type="slidenum">
               <a:rPr lang="de-DE" smtClean="0"/>
               <a:t>‹Nr.›</a:t>
             </a:fld>
@@ -723,7 +723,7 @@
     </p:spTree>
     <p:extLst>
       <p:ext uri="{BB962C8B-B14F-4D97-AF65-F5344CB8AC3E}">
-        <p14:creationId xmlns:p14="http://schemas.microsoft.com/office/powerpoint/2010/main" val="2696336013"/>
+        <p14:creationId xmlns:p14="http://schemas.microsoft.com/office/powerpoint/2010/main" val="378645259"/>
       </p:ext>
     </p:extLst>
   </p:cSld>
@@ -755,7 +755,7 @@
           <p:cNvPr id="2" name="Titel 1">
             <a:extLst>
               <a:ext uri="{FF2B5EF4-FFF2-40B4-BE49-F238E27FC236}">
-                <a16:creationId xmlns:a16="http://schemas.microsoft.com/office/drawing/2014/main" id="{0D802DF5-DB87-FB55-FE74-FD1F147BE3C0}"/>
+                <a16:creationId xmlns:a16="http://schemas.microsoft.com/office/drawing/2014/main" id="{90095338-C557-49C8-87D4-0014CC045913}"/>
               </a:ext>
             </a:extLst>
           </p:cNvPr>
@@ -783,7 +783,7 @@
           <p:cNvPr id="3" name="Inhaltsplatzhalter 2">
             <a:extLst>
               <a:ext uri="{FF2B5EF4-FFF2-40B4-BE49-F238E27FC236}">
-                <a16:creationId xmlns:a16="http://schemas.microsoft.com/office/drawing/2014/main" id="{60093A5F-159B-3B9E-1048-5E99D3DA0211}"/>
+                <a16:creationId xmlns:a16="http://schemas.microsoft.com/office/drawing/2014/main" id="{097F3FE2-3B0F-450A-BADE-C8CBC421D092}"/>
               </a:ext>
             </a:extLst>
           </p:cNvPr>
@@ -840,7 +840,7 @@
           <p:cNvPr id="4" name="Datumsplatzhalter 3">
             <a:extLst>
               <a:ext uri="{FF2B5EF4-FFF2-40B4-BE49-F238E27FC236}">
-                <a16:creationId xmlns:a16="http://schemas.microsoft.com/office/drawing/2014/main" id="{4720EAE3-431F-DA43-1A80-042A4CC040B6}"/>
+                <a16:creationId xmlns:a16="http://schemas.microsoft.com/office/drawing/2014/main" id="{E4CC8075-292B-4D29-8A8D-F1B43DC51D27}"/>
               </a:ext>
             </a:extLst>
           </p:cNvPr>
@@ -856,9 +856,9 @@
           <a:bodyPr/>
           <a:lstStyle/>
           <a:p>
-            <a:fld id="{D103C16D-CC5B-4681-8DC2-91DF2744339A}" type="datetimeFigureOut">
+            <a:fld id="{8DFE14BD-22BE-4CAC-BACA-BD69077A56DA}" type="datetimeFigureOut">
               <a:rPr lang="de-DE" smtClean="0"/>
-              <a:t>17.08.2026</a:t>
+              <a:t>04.09.2026</a:t>
             </a:fld>
             <a:endParaRPr lang="de-DE"/>
           </a:p>
@@ -869,7 +869,7 @@
           <p:cNvPr id="5" name="Fußzeilenplatzhalter 4">
             <a:extLst>
               <a:ext uri="{FF2B5EF4-FFF2-40B4-BE49-F238E27FC236}">
-                <a16:creationId xmlns:a16="http://schemas.microsoft.com/office/drawing/2014/main" id="{2A15BDE6-590F-AB7E-65C3-B9C101EC3A61}"/>
+                <a16:creationId xmlns:a16="http://schemas.microsoft.com/office/drawing/2014/main" id="{DA30F0F8-6966-44C7-ABAB-4F75EA82BCA4}"/>
               </a:ext>
             </a:extLst>
           </p:cNvPr>
@@ -894,7 +894,7 @@
           <p:cNvPr id="6" name="Foliennummernplatzhalter 5">
             <a:extLst>
               <a:ext uri="{FF2B5EF4-FFF2-40B4-BE49-F238E27FC236}">
-                <a16:creationId xmlns:a16="http://schemas.microsoft.com/office/drawing/2014/main" id="{22B59FC6-4655-0F61-C25D-85252F826CFE}"/>
+                <a16:creationId xmlns:a16="http://schemas.microsoft.com/office/drawing/2014/main" id="{D81DE609-2AE7-40C8-A9DC-8766A5AADAB6}"/>
               </a:ext>
             </a:extLst>
           </p:cNvPr>
@@ -910,7 +910,7 @@
           <a:bodyPr/>
           <a:lstStyle/>
           <a:p>
-            <a:fld id="{CCEF56B2-4225-4500-AB80-2ED1D5A5CA1B}" type="slidenum">
+            <a:fld id="{73257CB3-FA39-4251-BF0A-FFECE0B778D5}" type="slidenum">
               <a:rPr lang="de-DE" smtClean="0"/>
               <a:t>‹Nr.›</a:t>
             </a:fld>
@@ -921,7 +921,7 @@
     </p:spTree>
     <p:extLst>
       <p:ext uri="{BB962C8B-B14F-4D97-AF65-F5344CB8AC3E}">
-        <p14:creationId xmlns:p14="http://schemas.microsoft.com/office/powerpoint/2010/main" val="3399647422"/>
+        <p14:creationId xmlns:p14="http://schemas.microsoft.com/office/powerpoint/2010/main" val="3443726949"/>
       </p:ext>
     </p:extLst>
   </p:cSld>
@@ -953,7 +953,7 @@
           <p:cNvPr id="2" name="Titel 1">
             <a:extLst>
               <a:ext uri="{FF2B5EF4-FFF2-40B4-BE49-F238E27FC236}">
-                <a16:creationId xmlns:a16="http://schemas.microsoft.com/office/drawing/2014/main" id="{36186FA4-B40B-225C-0BCD-3F0229A47F47}"/>
+                <a16:creationId xmlns:a16="http://schemas.microsoft.com/office/drawing/2014/main" id="{17663C63-3C18-470A-A6A6-AFFD9D617982}"/>
               </a:ext>
             </a:extLst>
           </p:cNvPr>
@@ -990,7 +990,7 @@
           <p:cNvPr id="3" name="Textplatzhalter 2">
             <a:extLst>
               <a:ext uri="{FF2B5EF4-FFF2-40B4-BE49-F238E27FC236}">
-                <a16:creationId xmlns:a16="http://schemas.microsoft.com/office/drawing/2014/main" id="{62C429C5-1FDA-D8F3-5483-D9B85979E4C3}"/>
+                <a16:creationId xmlns:a16="http://schemas.microsoft.com/office/drawing/2014/main" id="{45843B26-C891-4C6D-9155-DA0BB0321584}"/>
               </a:ext>
             </a:extLst>
           </p:cNvPr>
@@ -1015,7 +1015,7 @@
               <a:defRPr sz="2045">
                 <a:solidFill>
                   <a:schemeClr val="tx1">
-                    <a:tint val="82000"/>
+                    <a:tint val="75000"/>
                   </a:schemeClr>
                 </a:solidFill>
               </a:defRPr>
@@ -1025,7 +1025,7 @@
               <a:defRPr sz="1704">
                 <a:solidFill>
                   <a:schemeClr val="tx1">
-                    <a:tint val="82000"/>
+                    <a:tint val="75000"/>
                   </a:schemeClr>
                 </a:solidFill>
               </a:defRPr>
@@ -1035,7 +1035,7 @@
               <a:defRPr sz="1533">
                 <a:solidFill>
                   <a:schemeClr val="tx1">
-                    <a:tint val="82000"/>
+                    <a:tint val="75000"/>
                   </a:schemeClr>
                 </a:solidFill>
               </a:defRPr>
@@ -1045,7 +1045,7 @@
               <a:defRPr sz="1363">
                 <a:solidFill>
                   <a:schemeClr val="tx1">
-                    <a:tint val="82000"/>
+                    <a:tint val="75000"/>
                   </a:schemeClr>
                 </a:solidFill>
               </a:defRPr>
@@ -1055,7 +1055,7 @@
               <a:defRPr sz="1363">
                 <a:solidFill>
                   <a:schemeClr val="tx1">
-                    <a:tint val="82000"/>
+                    <a:tint val="75000"/>
                   </a:schemeClr>
                 </a:solidFill>
               </a:defRPr>
@@ -1065,7 +1065,7 @@
               <a:defRPr sz="1363">
                 <a:solidFill>
                   <a:schemeClr val="tx1">
-                    <a:tint val="82000"/>
+                    <a:tint val="75000"/>
                   </a:schemeClr>
                 </a:solidFill>
               </a:defRPr>
@@ -1075,7 +1075,7 @@
               <a:defRPr sz="1363">
                 <a:solidFill>
                   <a:schemeClr val="tx1">
-                    <a:tint val="82000"/>
+                    <a:tint val="75000"/>
                   </a:schemeClr>
                 </a:solidFill>
               </a:defRPr>
@@ -1085,7 +1085,7 @@
               <a:defRPr sz="1363">
                 <a:solidFill>
                   <a:schemeClr val="tx1">
-                    <a:tint val="82000"/>
+                    <a:tint val="75000"/>
                   </a:schemeClr>
                 </a:solidFill>
               </a:defRPr>
@@ -1095,7 +1095,7 @@
               <a:defRPr sz="1363">
                 <a:solidFill>
                   <a:schemeClr val="tx1">
-                    <a:tint val="82000"/>
+                    <a:tint val="75000"/>
                   </a:schemeClr>
                 </a:solidFill>
               </a:defRPr>
@@ -1115,7 +1115,7 @@
           <p:cNvPr id="4" name="Datumsplatzhalter 3">
             <a:extLst>
               <a:ext uri="{FF2B5EF4-FFF2-40B4-BE49-F238E27FC236}">
-                <a16:creationId xmlns:a16="http://schemas.microsoft.com/office/drawing/2014/main" id="{B267DB9A-6D64-05C1-B3BF-F50D36721C60}"/>
+                <a16:creationId xmlns:a16="http://schemas.microsoft.com/office/drawing/2014/main" id="{857E66EE-2CC8-44DE-B473-D7EE51C2CA15}"/>
               </a:ext>
             </a:extLst>
           </p:cNvPr>
@@ -1131,9 +1131,9 @@
           <a:bodyPr/>
           <a:lstStyle/>
           <a:p>
-            <a:fld id="{D103C16D-CC5B-4681-8DC2-91DF2744339A}" type="datetimeFigureOut">
+            <a:fld id="{8DFE14BD-22BE-4CAC-BACA-BD69077A56DA}" type="datetimeFigureOut">
               <a:rPr lang="de-DE" smtClean="0"/>
-              <a:t>17.08.2026</a:t>
+              <a:t>04.09.2026</a:t>
             </a:fld>
             <a:endParaRPr lang="de-DE"/>
           </a:p>
@@ -1144,7 +1144,7 @@
           <p:cNvPr id="5" name="Fußzeilenplatzhalter 4">
             <a:extLst>
               <a:ext uri="{FF2B5EF4-FFF2-40B4-BE49-F238E27FC236}">
-                <a16:creationId xmlns:a16="http://schemas.microsoft.com/office/drawing/2014/main" id="{4932CD35-3432-B84C-190B-7C68D0A8A53C}"/>
+                <a16:creationId xmlns:a16="http://schemas.microsoft.com/office/drawing/2014/main" id="{A9285DD5-15D4-42F0-8B34-A905ED0A4574}"/>
               </a:ext>
             </a:extLst>
           </p:cNvPr>
@@ -1169,7 +1169,7 @@
           <p:cNvPr id="6" name="Foliennummernplatzhalter 5">
             <a:extLst>
               <a:ext uri="{FF2B5EF4-FFF2-40B4-BE49-F238E27FC236}">
-                <a16:creationId xmlns:a16="http://schemas.microsoft.com/office/drawing/2014/main" id="{93EA72B9-4D5E-36AB-C51C-4E2126805200}"/>
+                <a16:creationId xmlns:a16="http://schemas.microsoft.com/office/drawing/2014/main" id="{705A073E-FC9C-4A37-BB07-38C339BBE998}"/>
               </a:ext>
             </a:extLst>
           </p:cNvPr>
@@ -1185,7 +1185,7 @@
           <a:bodyPr/>
           <a:lstStyle/>
           <a:p>
-            <a:fld id="{CCEF56B2-4225-4500-AB80-2ED1D5A5CA1B}" type="slidenum">
+            <a:fld id="{73257CB3-FA39-4251-BF0A-FFECE0B778D5}" type="slidenum">
               <a:rPr lang="de-DE" smtClean="0"/>
               <a:t>‹Nr.›</a:t>
             </a:fld>
@@ -1196,7 +1196,7 @@
     </p:spTree>
     <p:extLst>
       <p:ext uri="{BB962C8B-B14F-4D97-AF65-F5344CB8AC3E}">
-        <p14:creationId xmlns:p14="http://schemas.microsoft.com/office/powerpoint/2010/main" val="3834285354"/>
+        <p14:creationId xmlns:p14="http://schemas.microsoft.com/office/powerpoint/2010/main" val="3453931732"/>
       </p:ext>
     </p:extLst>
   </p:cSld>
@@ -1228,7 +1228,7 @@
           <p:cNvPr id="2" name="Titel 1">
             <a:extLst>
               <a:ext uri="{FF2B5EF4-FFF2-40B4-BE49-F238E27FC236}">
-                <a16:creationId xmlns:a16="http://schemas.microsoft.com/office/drawing/2014/main" id="{CEFB5C8D-E017-FCA1-744F-6281DAB6D589}"/>
+                <a16:creationId xmlns:a16="http://schemas.microsoft.com/office/drawing/2014/main" id="{F6EFEC48-90E1-4677-8882-C5FFF466145B}"/>
               </a:ext>
             </a:extLst>
           </p:cNvPr>
@@ -1256,7 +1256,7 @@
           <p:cNvPr id="3" name="Inhaltsplatzhalter 2">
             <a:extLst>
               <a:ext uri="{FF2B5EF4-FFF2-40B4-BE49-F238E27FC236}">
-                <a16:creationId xmlns:a16="http://schemas.microsoft.com/office/drawing/2014/main" id="{A720EF57-45CA-111F-3B8E-985B05D47DEA}"/>
+                <a16:creationId xmlns:a16="http://schemas.microsoft.com/office/drawing/2014/main" id="{1BF5B083-7F79-48AC-8887-64E5E7BFCCB8}"/>
               </a:ext>
             </a:extLst>
           </p:cNvPr>
@@ -1318,7 +1318,7 @@
           <p:cNvPr id="4" name="Inhaltsplatzhalter 3">
             <a:extLst>
               <a:ext uri="{FF2B5EF4-FFF2-40B4-BE49-F238E27FC236}">
-                <a16:creationId xmlns:a16="http://schemas.microsoft.com/office/drawing/2014/main" id="{EE78EFB7-A3DE-82E0-E32C-984659512932}"/>
+                <a16:creationId xmlns:a16="http://schemas.microsoft.com/office/drawing/2014/main" id="{4E632F67-2D10-4DE4-A244-4AF061B1EA96}"/>
               </a:ext>
             </a:extLst>
           </p:cNvPr>
@@ -1380,7 +1380,7 @@
           <p:cNvPr id="5" name="Datumsplatzhalter 4">
             <a:extLst>
               <a:ext uri="{FF2B5EF4-FFF2-40B4-BE49-F238E27FC236}">
-                <a16:creationId xmlns:a16="http://schemas.microsoft.com/office/drawing/2014/main" id="{1BD4B3BA-0285-AD10-9809-72F627606F5B}"/>
+                <a16:creationId xmlns:a16="http://schemas.microsoft.com/office/drawing/2014/main" id="{4F3D46EF-AF80-4F53-AC97-F6543C41C318}"/>
               </a:ext>
             </a:extLst>
           </p:cNvPr>
@@ -1396,9 +1396,9 @@
           <a:bodyPr/>
           <a:lstStyle/>
           <a:p>
-            <a:fld id="{D103C16D-CC5B-4681-8DC2-91DF2744339A}" type="datetimeFigureOut">
+            <a:fld id="{8DFE14BD-22BE-4CAC-BACA-BD69077A56DA}" type="datetimeFigureOut">
               <a:rPr lang="de-DE" smtClean="0"/>
-              <a:t>17.08.2026</a:t>
+              <a:t>04.09.2026</a:t>
             </a:fld>
             <a:endParaRPr lang="de-DE"/>
           </a:p>
@@ -1409,7 +1409,7 @@
           <p:cNvPr id="6" name="Fußzeilenplatzhalter 5">
             <a:extLst>
               <a:ext uri="{FF2B5EF4-FFF2-40B4-BE49-F238E27FC236}">
-                <a16:creationId xmlns:a16="http://schemas.microsoft.com/office/drawing/2014/main" id="{665C975F-BC7C-649C-003F-06579E95DC79}"/>
+                <a16:creationId xmlns:a16="http://schemas.microsoft.com/office/drawing/2014/main" id="{EA0FECCB-DFE3-428C-8875-82D928BC628B}"/>
               </a:ext>
             </a:extLst>
           </p:cNvPr>
@@ -1434,7 +1434,7 @@
           <p:cNvPr id="7" name="Foliennummernplatzhalter 6">
             <a:extLst>
               <a:ext uri="{FF2B5EF4-FFF2-40B4-BE49-F238E27FC236}">
-                <a16:creationId xmlns:a16="http://schemas.microsoft.com/office/drawing/2014/main" id="{C9DBFE1D-ED3F-B94F-6E68-9A4ABDE820E8}"/>
+                <a16:creationId xmlns:a16="http://schemas.microsoft.com/office/drawing/2014/main" id="{FE5B9DA9-8BC0-438E-BCFA-CF9B27F18CE3}"/>
               </a:ext>
             </a:extLst>
           </p:cNvPr>
@@ -1450,7 +1450,7 @@
           <a:bodyPr/>
           <a:lstStyle/>
           <a:p>
-            <a:fld id="{CCEF56B2-4225-4500-AB80-2ED1D5A5CA1B}" type="slidenum">
+            <a:fld id="{73257CB3-FA39-4251-BF0A-FFECE0B778D5}" type="slidenum">
               <a:rPr lang="de-DE" smtClean="0"/>
               <a:t>‹Nr.›</a:t>
             </a:fld>
@@ -1461,7 +1461,7 @@
     </p:spTree>
     <p:extLst>
       <p:ext uri="{BB962C8B-B14F-4D97-AF65-F5344CB8AC3E}">
-        <p14:creationId xmlns:p14="http://schemas.microsoft.com/office/powerpoint/2010/main" val="3464453979"/>
+        <p14:creationId xmlns:p14="http://schemas.microsoft.com/office/powerpoint/2010/main" val="3857871036"/>
       </p:ext>
     </p:extLst>
   </p:cSld>
@@ -1493,7 +1493,7 @@
           <p:cNvPr id="2" name="Titel 1">
             <a:extLst>
               <a:ext uri="{FF2B5EF4-FFF2-40B4-BE49-F238E27FC236}">
-                <a16:creationId xmlns:a16="http://schemas.microsoft.com/office/drawing/2014/main" id="{52D70A96-4487-4911-C2BD-ABE4C4394F8A}"/>
+                <a16:creationId xmlns:a16="http://schemas.microsoft.com/office/drawing/2014/main" id="{C71150D7-A8F9-421D-897C-755FF65EF316}"/>
               </a:ext>
             </a:extLst>
           </p:cNvPr>
@@ -1526,7 +1526,7 @@
           <p:cNvPr id="3" name="Textplatzhalter 2">
             <a:extLst>
               <a:ext uri="{FF2B5EF4-FFF2-40B4-BE49-F238E27FC236}">
-                <a16:creationId xmlns:a16="http://schemas.microsoft.com/office/drawing/2014/main" id="{58367BC6-1C9B-69E4-3B14-C7CDBA2DC0D2}"/>
+                <a16:creationId xmlns:a16="http://schemas.microsoft.com/office/drawing/2014/main" id="{2AD2E6DA-D4B8-4EF8-976C-C4B8544F28D5}"/>
               </a:ext>
             </a:extLst>
           </p:cNvPr>
@@ -1597,7 +1597,7 @@
           <p:cNvPr id="4" name="Inhaltsplatzhalter 3">
             <a:extLst>
               <a:ext uri="{FF2B5EF4-FFF2-40B4-BE49-F238E27FC236}">
-                <a16:creationId xmlns:a16="http://schemas.microsoft.com/office/drawing/2014/main" id="{033E00F8-A103-C98E-D6CF-112F9E01AAA4}"/>
+                <a16:creationId xmlns:a16="http://schemas.microsoft.com/office/drawing/2014/main" id="{3BD9686E-D6CC-4FB7-AEC3-AA01EA055349}"/>
               </a:ext>
             </a:extLst>
           </p:cNvPr>
@@ -1659,7 +1659,7 @@
           <p:cNvPr id="5" name="Textplatzhalter 4">
             <a:extLst>
               <a:ext uri="{FF2B5EF4-FFF2-40B4-BE49-F238E27FC236}">
-                <a16:creationId xmlns:a16="http://schemas.microsoft.com/office/drawing/2014/main" id="{119D483A-6372-6659-F04D-F957F2F180D5}"/>
+                <a16:creationId xmlns:a16="http://schemas.microsoft.com/office/drawing/2014/main" id="{59D26BF7-3536-488F-B59E-0A5FE102428F}"/>
               </a:ext>
             </a:extLst>
           </p:cNvPr>
@@ -1730,7 +1730,7 @@
           <p:cNvPr id="6" name="Inhaltsplatzhalter 5">
             <a:extLst>
               <a:ext uri="{FF2B5EF4-FFF2-40B4-BE49-F238E27FC236}">
-                <a16:creationId xmlns:a16="http://schemas.microsoft.com/office/drawing/2014/main" id="{97B779E4-E597-ABB7-CA4F-785BA942D177}"/>
+                <a16:creationId xmlns:a16="http://schemas.microsoft.com/office/drawing/2014/main" id="{E34DBC54-87A6-4324-BBE7-40197CEB8711}"/>
               </a:ext>
             </a:extLst>
           </p:cNvPr>
@@ -1792,7 +1792,7 @@
           <p:cNvPr id="7" name="Datumsplatzhalter 6">
             <a:extLst>
               <a:ext uri="{FF2B5EF4-FFF2-40B4-BE49-F238E27FC236}">
-                <a16:creationId xmlns:a16="http://schemas.microsoft.com/office/drawing/2014/main" id="{C6D91ADD-DA82-1942-31F5-40EC8A404027}"/>
+                <a16:creationId xmlns:a16="http://schemas.microsoft.com/office/drawing/2014/main" id="{834091F5-ACC9-416A-BCE4-9DED7CF8599A}"/>
               </a:ext>
             </a:extLst>
           </p:cNvPr>
@@ -1808,9 +1808,9 @@
           <a:bodyPr/>
           <a:lstStyle/>
           <a:p>
-            <a:fld id="{D103C16D-CC5B-4681-8DC2-91DF2744339A}" type="datetimeFigureOut">
+            <a:fld id="{8DFE14BD-22BE-4CAC-BACA-BD69077A56DA}" type="datetimeFigureOut">
               <a:rPr lang="de-DE" smtClean="0"/>
-              <a:t>17.08.2026</a:t>
+              <a:t>04.09.2026</a:t>
             </a:fld>
             <a:endParaRPr lang="de-DE"/>
           </a:p>
@@ -1821,7 +1821,7 @@
           <p:cNvPr id="8" name="Fußzeilenplatzhalter 7">
             <a:extLst>
               <a:ext uri="{FF2B5EF4-FFF2-40B4-BE49-F238E27FC236}">
-                <a16:creationId xmlns:a16="http://schemas.microsoft.com/office/drawing/2014/main" id="{11F3467D-C8ED-8647-88D1-4FDAF12BDDBB}"/>
+                <a16:creationId xmlns:a16="http://schemas.microsoft.com/office/drawing/2014/main" id="{F3CE9900-8C40-4071-86CB-24A9B47541F6}"/>
               </a:ext>
             </a:extLst>
           </p:cNvPr>
@@ -1846,7 +1846,7 @@
           <p:cNvPr id="9" name="Foliennummernplatzhalter 8">
             <a:extLst>
               <a:ext uri="{FF2B5EF4-FFF2-40B4-BE49-F238E27FC236}">
-                <a16:creationId xmlns:a16="http://schemas.microsoft.com/office/drawing/2014/main" id="{ED33152B-8940-BABC-FD56-B0917C9E817F}"/>
+                <a16:creationId xmlns:a16="http://schemas.microsoft.com/office/drawing/2014/main" id="{2EA5433C-5B49-44C1-A61A-FBAAC3F0AC70}"/>
               </a:ext>
             </a:extLst>
           </p:cNvPr>
@@ -1862,7 +1862,7 @@
           <a:bodyPr/>
           <a:lstStyle/>
           <a:p>
-            <a:fld id="{CCEF56B2-4225-4500-AB80-2ED1D5A5CA1B}" type="slidenum">
+            <a:fld id="{73257CB3-FA39-4251-BF0A-FFECE0B778D5}" type="slidenum">
               <a:rPr lang="de-DE" smtClean="0"/>
               <a:t>‹Nr.›</a:t>
             </a:fld>
@@ -1873,7 +1873,7 @@
     </p:spTree>
     <p:extLst>
       <p:ext uri="{BB962C8B-B14F-4D97-AF65-F5344CB8AC3E}">
-        <p14:creationId xmlns:p14="http://schemas.microsoft.com/office/powerpoint/2010/main" val="1572128538"/>
+        <p14:creationId xmlns:p14="http://schemas.microsoft.com/office/powerpoint/2010/main" val="636338897"/>
       </p:ext>
     </p:extLst>
   </p:cSld>
@@ -1905,7 +1905,7 @@
           <p:cNvPr id="2" name="Titel 1">
             <a:extLst>
               <a:ext uri="{FF2B5EF4-FFF2-40B4-BE49-F238E27FC236}">
-                <a16:creationId xmlns:a16="http://schemas.microsoft.com/office/drawing/2014/main" id="{D27B3F7C-839D-5D19-D3E8-6C86465A3EDA}"/>
+                <a16:creationId xmlns:a16="http://schemas.microsoft.com/office/drawing/2014/main" id="{A87EDB8B-9968-47A9-ADC1-2A919D4812F1}"/>
               </a:ext>
             </a:extLst>
           </p:cNvPr>
@@ -1933,7 +1933,7 @@
           <p:cNvPr id="3" name="Datumsplatzhalter 2">
             <a:extLst>
               <a:ext uri="{FF2B5EF4-FFF2-40B4-BE49-F238E27FC236}">
-                <a16:creationId xmlns:a16="http://schemas.microsoft.com/office/drawing/2014/main" id="{E827BC8A-1015-B7C2-4C1D-81C44C5FF711}"/>
+                <a16:creationId xmlns:a16="http://schemas.microsoft.com/office/drawing/2014/main" id="{A1D7393E-13F8-40D3-8D49-145E5BE95463}"/>
               </a:ext>
             </a:extLst>
           </p:cNvPr>
@@ -1949,9 +1949,9 @@
           <a:bodyPr/>
           <a:lstStyle/>
           <a:p>
-            <a:fld id="{D103C16D-CC5B-4681-8DC2-91DF2744339A}" type="datetimeFigureOut">
+            <a:fld id="{8DFE14BD-22BE-4CAC-BACA-BD69077A56DA}" type="datetimeFigureOut">
               <a:rPr lang="de-DE" smtClean="0"/>
-              <a:t>17.08.2026</a:t>
+              <a:t>04.09.2026</a:t>
             </a:fld>
             <a:endParaRPr lang="de-DE"/>
           </a:p>
@@ -1962,7 +1962,7 @@
           <p:cNvPr id="4" name="Fußzeilenplatzhalter 3">
             <a:extLst>
               <a:ext uri="{FF2B5EF4-FFF2-40B4-BE49-F238E27FC236}">
-                <a16:creationId xmlns:a16="http://schemas.microsoft.com/office/drawing/2014/main" id="{FD78E7E2-C4EF-EE46-FFD1-C771F878D91A}"/>
+                <a16:creationId xmlns:a16="http://schemas.microsoft.com/office/drawing/2014/main" id="{304A20C3-A606-40B6-BBDF-0371D830B98D}"/>
               </a:ext>
             </a:extLst>
           </p:cNvPr>
@@ -1987,7 +1987,7 @@
           <p:cNvPr id="5" name="Foliennummernplatzhalter 4">
             <a:extLst>
               <a:ext uri="{FF2B5EF4-FFF2-40B4-BE49-F238E27FC236}">
-                <a16:creationId xmlns:a16="http://schemas.microsoft.com/office/drawing/2014/main" id="{642FC956-E096-85DD-F43A-FAFD8D7B784B}"/>
+                <a16:creationId xmlns:a16="http://schemas.microsoft.com/office/drawing/2014/main" id="{C9277D41-8FD4-41BF-9496-7F2014027DA8}"/>
               </a:ext>
             </a:extLst>
           </p:cNvPr>
@@ -2003,7 +2003,7 @@
           <a:bodyPr/>
           <a:lstStyle/>
           <a:p>
-            <a:fld id="{CCEF56B2-4225-4500-AB80-2ED1D5A5CA1B}" type="slidenum">
+            <a:fld id="{73257CB3-FA39-4251-BF0A-FFECE0B778D5}" type="slidenum">
               <a:rPr lang="de-DE" smtClean="0"/>
               <a:t>‹Nr.›</a:t>
             </a:fld>
@@ -2014,7 +2014,7 @@
     </p:spTree>
     <p:extLst>
       <p:ext uri="{BB962C8B-B14F-4D97-AF65-F5344CB8AC3E}">
-        <p14:creationId xmlns:p14="http://schemas.microsoft.com/office/powerpoint/2010/main" val="4034336210"/>
+        <p14:creationId xmlns:p14="http://schemas.microsoft.com/office/powerpoint/2010/main" val="851317584"/>
       </p:ext>
     </p:extLst>
   </p:cSld>
@@ -2046,7 +2046,7 @@
           <p:cNvPr id="2" name="Datumsplatzhalter 1">
             <a:extLst>
               <a:ext uri="{FF2B5EF4-FFF2-40B4-BE49-F238E27FC236}">
-                <a16:creationId xmlns:a16="http://schemas.microsoft.com/office/drawing/2014/main" id="{E9E15A82-B27A-7908-4A7C-5D07AAC43679}"/>
+                <a16:creationId xmlns:a16="http://schemas.microsoft.com/office/drawing/2014/main" id="{331AC305-0FF6-4773-88C3-1F4714279318}"/>
               </a:ext>
             </a:extLst>
           </p:cNvPr>
@@ -2062,9 +2062,9 @@
           <a:bodyPr/>
           <a:lstStyle/>
           <a:p>
-            <a:fld id="{D103C16D-CC5B-4681-8DC2-91DF2744339A}" type="datetimeFigureOut">
+            <a:fld id="{8DFE14BD-22BE-4CAC-BACA-BD69077A56DA}" type="datetimeFigureOut">
               <a:rPr lang="de-DE" smtClean="0"/>
-              <a:t>17.08.2026</a:t>
+              <a:t>04.09.2026</a:t>
             </a:fld>
             <a:endParaRPr lang="de-DE"/>
           </a:p>
@@ -2075,7 +2075,7 @@
           <p:cNvPr id="3" name="Fußzeilenplatzhalter 2">
             <a:extLst>
               <a:ext uri="{FF2B5EF4-FFF2-40B4-BE49-F238E27FC236}">
-                <a16:creationId xmlns:a16="http://schemas.microsoft.com/office/drawing/2014/main" id="{A78CF119-FFE5-AC09-27E1-5BAE70913E23}"/>
+                <a16:creationId xmlns:a16="http://schemas.microsoft.com/office/drawing/2014/main" id="{DB439883-233A-4B26-A4A5-9CAFF3893747}"/>
               </a:ext>
             </a:extLst>
           </p:cNvPr>
@@ -2100,7 +2100,7 @@
           <p:cNvPr id="4" name="Foliennummernplatzhalter 3">
             <a:extLst>
               <a:ext uri="{FF2B5EF4-FFF2-40B4-BE49-F238E27FC236}">
-                <a16:creationId xmlns:a16="http://schemas.microsoft.com/office/drawing/2014/main" id="{7453FC7A-F00A-1CFB-CDEF-967F73E8E4EE}"/>
+                <a16:creationId xmlns:a16="http://schemas.microsoft.com/office/drawing/2014/main" id="{CF56A270-9A03-4196-A9B8-08C32EDE4778}"/>
               </a:ext>
             </a:extLst>
           </p:cNvPr>
@@ -2116,7 +2116,7 @@
           <a:bodyPr/>
           <a:lstStyle/>
           <a:p>
-            <a:fld id="{CCEF56B2-4225-4500-AB80-2ED1D5A5CA1B}" type="slidenum">
+            <a:fld id="{73257CB3-FA39-4251-BF0A-FFECE0B778D5}" type="slidenum">
               <a:rPr lang="de-DE" smtClean="0"/>
               <a:t>‹Nr.›</a:t>
             </a:fld>
@@ -2127,7 +2127,7 @@
     </p:spTree>
     <p:extLst>
       <p:ext uri="{BB962C8B-B14F-4D97-AF65-F5344CB8AC3E}">
-        <p14:creationId xmlns:p14="http://schemas.microsoft.com/office/powerpoint/2010/main" val="1512153689"/>
+        <p14:creationId xmlns:p14="http://schemas.microsoft.com/office/powerpoint/2010/main" val="4219575808"/>
       </p:ext>
     </p:extLst>
   </p:cSld>
@@ -2159,7 +2159,7 @@
           <p:cNvPr id="2" name="Titel 1">
             <a:extLst>
               <a:ext uri="{FF2B5EF4-FFF2-40B4-BE49-F238E27FC236}">
-                <a16:creationId xmlns:a16="http://schemas.microsoft.com/office/drawing/2014/main" id="{7A7CD9DC-6597-6883-1F5C-4991C9B7CF2F}"/>
+                <a16:creationId xmlns:a16="http://schemas.microsoft.com/office/drawing/2014/main" id="{E6AAA1B3-F484-4EAB-B00C-A98CB10C1923}"/>
               </a:ext>
             </a:extLst>
           </p:cNvPr>
@@ -2196,7 +2196,7 @@
           <p:cNvPr id="3" name="Inhaltsplatzhalter 2">
             <a:extLst>
               <a:ext uri="{FF2B5EF4-FFF2-40B4-BE49-F238E27FC236}">
-                <a16:creationId xmlns:a16="http://schemas.microsoft.com/office/drawing/2014/main" id="{D8563E31-3E1E-89A0-BBD1-1EE6CEF0E3A0}"/>
+                <a16:creationId xmlns:a16="http://schemas.microsoft.com/office/drawing/2014/main" id="{0D245FBF-711A-4A11-975E-3E5E842E27D8}"/>
               </a:ext>
             </a:extLst>
           </p:cNvPr>
@@ -2286,7 +2286,7 @@
           <p:cNvPr id="4" name="Textplatzhalter 3">
             <a:extLst>
               <a:ext uri="{FF2B5EF4-FFF2-40B4-BE49-F238E27FC236}">
-                <a16:creationId xmlns:a16="http://schemas.microsoft.com/office/drawing/2014/main" id="{9FF59835-49EB-05EB-FF80-21E12E0587C7}"/>
+                <a16:creationId xmlns:a16="http://schemas.microsoft.com/office/drawing/2014/main" id="{DF37D314-B163-4EA2-8F1E-211149C35F6F}"/>
               </a:ext>
             </a:extLst>
           </p:cNvPr>
@@ -2357,7 +2357,7 @@
           <p:cNvPr id="5" name="Datumsplatzhalter 4">
             <a:extLst>
               <a:ext uri="{FF2B5EF4-FFF2-40B4-BE49-F238E27FC236}">
-                <a16:creationId xmlns:a16="http://schemas.microsoft.com/office/drawing/2014/main" id="{C82DA6E0-7CED-D0A3-D54A-FBE70EB8A5E7}"/>
+                <a16:creationId xmlns:a16="http://schemas.microsoft.com/office/drawing/2014/main" id="{499EF918-9BAE-498E-9AC0-272A2DD1E42A}"/>
               </a:ext>
             </a:extLst>
           </p:cNvPr>
@@ -2373,9 +2373,9 @@
           <a:bodyPr/>
           <a:lstStyle/>
           <a:p>
-            <a:fld id="{D103C16D-CC5B-4681-8DC2-91DF2744339A}" type="datetimeFigureOut">
+            <a:fld id="{8DFE14BD-22BE-4CAC-BACA-BD69077A56DA}" type="datetimeFigureOut">
               <a:rPr lang="de-DE" smtClean="0"/>
-              <a:t>17.08.2026</a:t>
+              <a:t>04.09.2026</a:t>
             </a:fld>
             <a:endParaRPr lang="de-DE"/>
           </a:p>
@@ -2386,7 +2386,7 @@
           <p:cNvPr id="6" name="Fußzeilenplatzhalter 5">
             <a:extLst>
               <a:ext uri="{FF2B5EF4-FFF2-40B4-BE49-F238E27FC236}">
-                <a16:creationId xmlns:a16="http://schemas.microsoft.com/office/drawing/2014/main" id="{F94312F6-96DB-1864-C67F-B301DFD7DACC}"/>
+                <a16:creationId xmlns:a16="http://schemas.microsoft.com/office/drawing/2014/main" id="{CB4013F5-7992-4E6D-B1D2-8AC87E9541BB}"/>
               </a:ext>
             </a:extLst>
           </p:cNvPr>
@@ -2411,7 +2411,7 @@
           <p:cNvPr id="7" name="Foliennummernplatzhalter 6">
             <a:extLst>
               <a:ext uri="{FF2B5EF4-FFF2-40B4-BE49-F238E27FC236}">
-                <a16:creationId xmlns:a16="http://schemas.microsoft.com/office/drawing/2014/main" id="{5183B54C-2525-13FB-85EE-F4805B12D2FA}"/>
+                <a16:creationId xmlns:a16="http://schemas.microsoft.com/office/drawing/2014/main" id="{CEFBD202-2441-4F82-9D84-E2EB9A00FD1A}"/>
               </a:ext>
             </a:extLst>
           </p:cNvPr>
@@ -2427,7 +2427,7 @@
           <a:bodyPr/>
           <a:lstStyle/>
           <a:p>
-            <a:fld id="{CCEF56B2-4225-4500-AB80-2ED1D5A5CA1B}" type="slidenum">
+            <a:fld id="{73257CB3-FA39-4251-BF0A-FFECE0B778D5}" type="slidenum">
               <a:rPr lang="de-DE" smtClean="0"/>
               <a:t>‹Nr.›</a:t>
             </a:fld>
@@ -2438,7 +2438,7 @@
     </p:spTree>
     <p:extLst>
       <p:ext uri="{BB962C8B-B14F-4D97-AF65-F5344CB8AC3E}">
-        <p14:creationId xmlns:p14="http://schemas.microsoft.com/office/powerpoint/2010/main" val="787266069"/>
+        <p14:creationId xmlns:p14="http://schemas.microsoft.com/office/powerpoint/2010/main" val="3678986033"/>
       </p:ext>
     </p:extLst>
   </p:cSld>
@@ -2470,7 +2470,7 @@
           <p:cNvPr id="2" name="Titel 1">
             <a:extLst>
               <a:ext uri="{FF2B5EF4-FFF2-40B4-BE49-F238E27FC236}">
-                <a16:creationId xmlns:a16="http://schemas.microsoft.com/office/drawing/2014/main" id="{DB2CD1E4-5763-3567-7602-B3EEC2E9084E}"/>
+                <a16:creationId xmlns:a16="http://schemas.microsoft.com/office/drawing/2014/main" id="{8B98D870-3AD9-4E49-B5DF-AA7AE6DC916B}"/>
               </a:ext>
             </a:extLst>
           </p:cNvPr>
@@ -2507,7 +2507,7 @@
           <p:cNvPr id="3" name="Bildplatzhalter 2">
             <a:extLst>
               <a:ext uri="{FF2B5EF4-FFF2-40B4-BE49-F238E27FC236}">
-                <a16:creationId xmlns:a16="http://schemas.microsoft.com/office/drawing/2014/main" id="{FA474D37-3C46-2959-3A47-5FC8972F0E02}"/>
+                <a16:creationId xmlns:a16="http://schemas.microsoft.com/office/drawing/2014/main" id="{61AE96E4-3946-454A-8076-08C26BFB1941}"/>
               </a:ext>
             </a:extLst>
           </p:cNvPr>
@@ -2574,7 +2574,7 @@
           <p:cNvPr id="4" name="Textplatzhalter 3">
             <a:extLst>
               <a:ext uri="{FF2B5EF4-FFF2-40B4-BE49-F238E27FC236}">
-                <a16:creationId xmlns:a16="http://schemas.microsoft.com/office/drawing/2014/main" id="{E2E1437C-AE4D-B378-AE6B-26EDAA04A17E}"/>
+                <a16:creationId xmlns:a16="http://schemas.microsoft.com/office/drawing/2014/main" id="{F9D306D9-FEE9-47AB-B805-FA649788B4C2}"/>
               </a:ext>
             </a:extLst>
           </p:cNvPr>
@@ -2645,7 +2645,7 @@
           <p:cNvPr id="5" name="Datumsplatzhalter 4">
             <a:extLst>
               <a:ext uri="{FF2B5EF4-FFF2-40B4-BE49-F238E27FC236}">
-                <a16:creationId xmlns:a16="http://schemas.microsoft.com/office/drawing/2014/main" id="{689956C5-C5BE-D3A2-DB4F-904E8382D38B}"/>
+                <a16:creationId xmlns:a16="http://schemas.microsoft.com/office/drawing/2014/main" id="{7D6E4B94-A47C-4840-8363-4DD860AB9331}"/>
               </a:ext>
             </a:extLst>
           </p:cNvPr>
@@ -2661,9 +2661,9 @@
           <a:bodyPr/>
           <a:lstStyle/>
           <a:p>
-            <a:fld id="{D103C16D-CC5B-4681-8DC2-91DF2744339A}" type="datetimeFigureOut">
+            <a:fld id="{8DFE14BD-22BE-4CAC-BACA-BD69077A56DA}" type="datetimeFigureOut">
               <a:rPr lang="de-DE" smtClean="0"/>
-              <a:t>17.08.2026</a:t>
+              <a:t>04.09.2026</a:t>
             </a:fld>
             <a:endParaRPr lang="de-DE"/>
           </a:p>
@@ -2674,7 +2674,7 @@
           <p:cNvPr id="6" name="Fußzeilenplatzhalter 5">
             <a:extLst>
               <a:ext uri="{FF2B5EF4-FFF2-40B4-BE49-F238E27FC236}">
-                <a16:creationId xmlns:a16="http://schemas.microsoft.com/office/drawing/2014/main" id="{5BD547AF-98A3-21BF-96F5-186ED156EA68}"/>
+                <a16:creationId xmlns:a16="http://schemas.microsoft.com/office/drawing/2014/main" id="{4EF017A1-7DB0-44F5-8FDB-C7767A4E005A}"/>
               </a:ext>
             </a:extLst>
           </p:cNvPr>
@@ -2699,7 +2699,7 @@
           <p:cNvPr id="7" name="Foliennummernplatzhalter 6">
             <a:extLst>
               <a:ext uri="{FF2B5EF4-FFF2-40B4-BE49-F238E27FC236}">
-                <a16:creationId xmlns:a16="http://schemas.microsoft.com/office/drawing/2014/main" id="{C17323F7-D3B4-404C-0336-F5F72DA36807}"/>
+                <a16:creationId xmlns:a16="http://schemas.microsoft.com/office/drawing/2014/main" id="{9157A16F-CCC7-48CF-BA04-890EB0CE9305}"/>
               </a:ext>
             </a:extLst>
           </p:cNvPr>
@@ -2715,7 +2715,7 @@
           <a:bodyPr/>
           <a:lstStyle/>
           <a:p>
-            <a:fld id="{CCEF56B2-4225-4500-AB80-2ED1D5A5CA1B}" type="slidenum">
+            <a:fld id="{73257CB3-FA39-4251-BF0A-FFECE0B778D5}" type="slidenum">
               <a:rPr lang="de-DE" smtClean="0"/>
               <a:t>‹Nr.›</a:t>
             </a:fld>
@@ -2726,7 +2726,7 @@
     </p:spTree>
     <p:extLst>
       <p:ext uri="{BB962C8B-B14F-4D97-AF65-F5344CB8AC3E}">
-        <p14:creationId xmlns:p14="http://schemas.microsoft.com/office/powerpoint/2010/main" val="1531346189"/>
+        <p14:creationId xmlns:p14="http://schemas.microsoft.com/office/powerpoint/2010/main" val="716556959"/>
       </p:ext>
     </p:extLst>
   </p:cSld>
@@ -2763,7 +2763,7 @@
           <p:cNvPr id="2" name="Titelplatzhalter 1">
             <a:extLst>
               <a:ext uri="{FF2B5EF4-FFF2-40B4-BE49-F238E27FC236}">
-                <a16:creationId xmlns:a16="http://schemas.microsoft.com/office/drawing/2014/main" id="{946B1E96-E1A7-A74D-710F-20E0882F6B3D}"/>
+                <a16:creationId xmlns:a16="http://schemas.microsoft.com/office/drawing/2014/main" id="{10AA71BD-ADA3-4FD2-A5E1-04558D48E5ED}"/>
               </a:ext>
             </a:extLst>
           </p:cNvPr>
@@ -2801,7 +2801,7 @@
           <p:cNvPr id="3" name="Textplatzhalter 2">
             <a:extLst>
               <a:ext uri="{FF2B5EF4-FFF2-40B4-BE49-F238E27FC236}">
-                <a16:creationId xmlns:a16="http://schemas.microsoft.com/office/drawing/2014/main" id="{A3482942-7D08-7A1C-A1BC-8272BDDBB35D}"/>
+                <a16:creationId xmlns:a16="http://schemas.microsoft.com/office/drawing/2014/main" id="{8CAF82F1-B129-4DE1-AB13-04A2788836DE}"/>
               </a:ext>
             </a:extLst>
           </p:cNvPr>
@@ -2868,7 +2868,7 @@
           <p:cNvPr id="4" name="Datumsplatzhalter 3">
             <a:extLst>
               <a:ext uri="{FF2B5EF4-FFF2-40B4-BE49-F238E27FC236}">
-                <a16:creationId xmlns:a16="http://schemas.microsoft.com/office/drawing/2014/main" id="{AD8CE1EF-6FEF-C149-32F6-C9B2B8D249DA}"/>
+                <a16:creationId xmlns:a16="http://schemas.microsoft.com/office/drawing/2014/main" id="{8B7730BE-1DCE-4220-9BB3-24806850D96E}"/>
               </a:ext>
             </a:extLst>
           </p:cNvPr>
@@ -2895,16 +2895,16 @@
               <a:defRPr sz="1022">
                 <a:solidFill>
                   <a:schemeClr val="tx1">
-                    <a:tint val="82000"/>
+                    <a:tint val="75000"/>
                   </a:schemeClr>
                 </a:solidFill>
               </a:defRPr>
             </a:lvl1pPr>
           </a:lstStyle>
           <a:p>
-            <a:fld id="{D103C16D-CC5B-4681-8DC2-91DF2744339A}" type="datetimeFigureOut">
+            <a:fld id="{8DFE14BD-22BE-4CAC-BACA-BD69077A56DA}" type="datetimeFigureOut">
               <a:rPr lang="de-DE" smtClean="0"/>
-              <a:t>17.08.2026</a:t>
+              <a:t>04.09.2026</a:t>
             </a:fld>
             <a:endParaRPr lang="de-DE"/>
           </a:p>
@@ -2915,7 +2915,7 @@
           <p:cNvPr id="5" name="Fußzeilenplatzhalter 4">
             <a:extLst>
               <a:ext uri="{FF2B5EF4-FFF2-40B4-BE49-F238E27FC236}">
-                <a16:creationId xmlns:a16="http://schemas.microsoft.com/office/drawing/2014/main" id="{71DE8681-16E6-1CE1-244E-DB8C3B939FD2}"/>
+                <a16:creationId xmlns:a16="http://schemas.microsoft.com/office/drawing/2014/main" id="{63BA2F8C-1E95-4364-8DFA-7D219B1243CA}"/>
               </a:ext>
             </a:extLst>
           </p:cNvPr>
@@ -2942,7 +2942,7 @@
               <a:defRPr sz="1022">
                 <a:solidFill>
                   <a:schemeClr val="tx1">
-                    <a:tint val="82000"/>
+                    <a:tint val="75000"/>
                   </a:schemeClr>
                 </a:solidFill>
               </a:defRPr>
@@ -2958,7 +2958,7 @@
           <p:cNvPr id="6" name="Foliennummernplatzhalter 5">
             <a:extLst>
               <a:ext uri="{FF2B5EF4-FFF2-40B4-BE49-F238E27FC236}">
-                <a16:creationId xmlns:a16="http://schemas.microsoft.com/office/drawing/2014/main" id="{F15B5E6B-F761-8B21-A47A-F92DE7E9E1BA}"/>
+                <a16:creationId xmlns:a16="http://schemas.microsoft.com/office/drawing/2014/main" id="{FC6FB4E4-8277-449C-8DAF-9E2816D45DCB}"/>
               </a:ext>
             </a:extLst>
           </p:cNvPr>
@@ -2985,14 +2985,14 @@
               <a:defRPr sz="1022">
                 <a:solidFill>
                   <a:schemeClr val="tx1">
-                    <a:tint val="82000"/>
+                    <a:tint val="75000"/>
                   </a:schemeClr>
                 </a:solidFill>
               </a:defRPr>
             </a:lvl1pPr>
           </a:lstStyle>
           <a:p>
-            <a:fld id="{CCEF56B2-4225-4500-AB80-2ED1D5A5CA1B}" type="slidenum">
+            <a:fld id="{73257CB3-FA39-4251-BF0A-FFECE0B778D5}" type="slidenum">
               <a:rPr lang="de-DE" smtClean="0"/>
               <a:t>‹Nr.›</a:t>
             </a:fld>
@@ -3003,7 +3003,7 @@
     </p:spTree>
     <p:extLst>
       <p:ext uri="{BB962C8B-B14F-4D97-AF65-F5344CB8AC3E}">
-        <p14:creationId xmlns:p14="http://schemas.microsoft.com/office/powerpoint/2010/main" val="1841410257"/>
+        <p14:creationId xmlns:p14="http://schemas.microsoft.com/office/powerpoint/2010/main" val="871623745"/>
       </p:ext>
     </p:extLst>
   </p:cSld>
@@ -3332,7 +3332,7 @@
           <p:cNvPr id="2" name="Textfeld 1">
             <a:extLst>
               <a:ext uri="{FF2B5EF4-FFF2-40B4-BE49-F238E27FC236}">
-                <a16:creationId xmlns:a16="http://schemas.microsoft.com/office/drawing/2014/main" id="{C70F06A9-82CC-C6E5-6E97-DFE817C530E1}"/>
+                <a16:creationId xmlns:a16="http://schemas.microsoft.com/office/drawing/2014/main" id="{ABB8893D-D5B7-48AD-946A-B74115386012}"/>
               </a:ext>
             </a:extLst>
           </p:cNvPr>
@@ -3372,7 +3372,7 @@
           <p:cNvPr id="3" name="Gerader Verbinder 2">
             <a:extLst>
               <a:ext uri="{FF2B5EF4-FFF2-40B4-BE49-F238E27FC236}">
-                <a16:creationId xmlns:a16="http://schemas.microsoft.com/office/drawing/2014/main" id="{7C528EFE-5AA0-5090-6CCC-FAAC32058DC4}"/>
+                <a16:creationId xmlns:a16="http://schemas.microsoft.com/office/drawing/2014/main" id="{BBEE9EB3-FD9F-4D77-BDD9-439043185868}"/>
               </a:ext>
             </a:extLst>
           </p:cNvPr>
@@ -3394,13 +3394,13 @@
           </a:ln>
         </p:spPr>
         <p:style>
-          <a:lnRef idx="2">
+          <a:lnRef idx="1">
             <a:schemeClr val="accent1"/>
           </a:lnRef>
           <a:fillRef idx="0">
             <a:schemeClr val="accent1"/>
           </a:fillRef>
-          <a:effectRef idx="1">
+          <a:effectRef idx="0">
             <a:schemeClr val="accent1"/>
           </a:effectRef>
           <a:fontRef idx="minor">
@@ -3413,7 +3413,7 @@
           <p:cNvPr id="4" name="Textfeld 3">
             <a:extLst>
               <a:ext uri="{FF2B5EF4-FFF2-40B4-BE49-F238E27FC236}">
-                <a16:creationId xmlns:a16="http://schemas.microsoft.com/office/drawing/2014/main" id="{5C9C5F94-7676-984C-B9D1-81C607EC612F}"/>
+                <a16:creationId xmlns:a16="http://schemas.microsoft.com/office/drawing/2014/main" id="{F0B723D5-8B2F-4924-B73E-7B452BADE798}"/>
               </a:ext>
             </a:extLst>
           </p:cNvPr>
@@ -3422,8 +3422,8 @@
         </p:nvSpPr>
         <p:spPr>
           <a:xfrm>
-            <a:off x="355600" y="4318000"/>
-            <a:ext cx="482600" cy="153888"/>
+            <a:off x="317500" y="4305300"/>
+            <a:ext cx="520700" cy="169277"/>
           </a:xfrm>
           <a:prstGeom prst="rect">
             <a:avLst/>
@@ -3438,7 +3438,7 @@
           <a:p>
             <a:pPr algn="r"/>
             <a:r>
-              <a:rPr lang="de-DE" sz="1000">
+              <a:rPr lang="de-DE" sz="1100">
                 <a:solidFill>
                   <a:srgbClr val="222222"/>
                 </a:solidFill>
@@ -3454,7 +3454,7 @@
           <p:cNvPr id="5" name="Gerader Verbinder 4">
             <a:extLst>
               <a:ext uri="{FF2B5EF4-FFF2-40B4-BE49-F238E27FC236}">
-                <a16:creationId xmlns:a16="http://schemas.microsoft.com/office/drawing/2014/main" id="{60296F31-D8B2-5E56-5487-35D4A584D5AE}"/>
+                <a16:creationId xmlns:a16="http://schemas.microsoft.com/office/drawing/2014/main" id="{3348AF29-9E15-4B4D-A3C4-68CAD2456445}"/>
               </a:ext>
             </a:extLst>
           </p:cNvPr>
@@ -3463,7 +3463,7 @@
         </p:nvCxnSpPr>
         <p:spPr>
           <a:xfrm>
-            <a:off x="914400" y="3467100"/>
+            <a:off x="914400" y="3657600"/>
             <a:ext cx="5207000" cy="0"/>
           </a:xfrm>
           <a:prstGeom prst="line">
@@ -3477,13 +3477,13 @@
           </a:ln>
         </p:spPr>
         <p:style>
-          <a:lnRef idx="2">
+          <a:lnRef idx="1">
             <a:schemeClr val="accent1"/>
           </a:lnRef>
           <a:fillRef idx="0">
             <a:schemeClr val="accent1"/>
           </a:fillRef>
-          <a:effectRef idx="1">
+          <a:effectRef idx="0">
             <a:schemeClr val="accent1"/>
           </a:effectRef>
           <a:fontRef idx="minor">
@@ -3496,7 +3496,7 @@
           <p:cNvPr id="6" name="Textfeld 5">
             <a:extLst>
               <a:ext uri="{FF2B5EF4-FFF2-40B4-BE49-F238E27FC236}">
-                <a16:creationId xmlns:a16="http://schemas.microsoft.com/office/drawing/2014/main" id="{87D02C10-3D75-685F-C347-CD41A794253F}"/>
+                <a16:creationId xmlns:a16="http://schemas.microsoft.com/office/drawing/2014/main" id="{6C026EE3-42F5-447A-A422-820C73A6B111}"/>
               </a:ext>
             </a:extLst>
           </p:cNvPr>
@@ -3505,8 +3505,8 @@
         </p:nvSpPr>
         <p:spPr>
           <a:xfrm>
-            <a:off x="355600" y="3365500"/>
-            <a:ext cx="482600" cy="153888"/>
+            <a:off x="317500" y="3543300"/>
+            <a:ext cx="520700" cy="169277"/>
           </a:xfrm>
           <a:prstGeom prst="rect">
             <a:avLst/>
@@ -3521,7 +3521,7 @@
           <a:p>
             <a:pPr algn="r"/>
             <a:r>
-              <a:rPr lang="de-DE" sz="1000">
+              <a:rPr lang="de-DE" sz="1100">
                 <a:solidFill>
                   <a:srgbClr val="222222"/>
                 </a:solidFill>
@@ -3537,7 +3537,7 @@
           <p:cNvPr id="7" name="Gerader Verbinder 6">
             <a:extLst>
               <a:ext uri="{FF2B5EF4-FFF2-40B4-BE49-F238E27FC236}">
-                <a16:creationId xmlns:a16="http://schemas.microsoft.com/office/drawing/2014/main" id="{5A36D069-776E-E69E-0AFD-94A1D3B48F96}"/>
+                <a16:creationId xmlns:a16="http://schemas.microsoft.com/office/drawing/2014/main" id="{C3555193-B346-4652-9690-0B68A9F229C1}"/>
               </a:ext>
             </a:extLst>
           </p:cNvPr>
@@ -3546,7 +3546,7 @@
         </p:nvCxnSpPr>
         <p:spPr>
           <a:xfrm>
-            <a:off x="914400" y="2514600"/>
+            <a:off x="914400" y="2895600"/>
             <a:ext cx="5207000" cy="0"/>
           </a:xfrm>
           <a:prstGeom prst="line">
@@ -3560,13 +3560,13 @@
           </a:ln>
         </p:spPr>
         <p:style>
-          <a:lnRef idx="2">
+          <a:lnRef idx="1">
             <a:schemeClr val="accent1"/>
           </a:lnRef>
           <a:fillRef idx="0">
             <a:schemeClr val="accent1"/>
           </a:fillRef>
-          <a:effectRef idx="1">
+          <a:effectRef idx="0">
             <a:schemeClr val="accent1"/>
           </a:effectRef>
           <a:fontRef idx="minor">
@@ -3579,7 +3579,7 @@
           <p:cNvPr id="8" name="Textfeld 7">
             <a:extLst>
               <a:ext uri="{FF2B5EF4-FFF2-40B4-BE49-F238E27FC236}">
-                <a16:creationId xmlns:a16="http://schemas.microsoft.com/office/drawing/2014/main" id="{B318A4E8-8175-A401-7568-9FAA9C264945}"/>
+                <a16:creationId xmlns:a16="http://schemas.microsoft.com/office/drawing/2014/main" id="{C1340EF4-D28F-4C84-85C3-030086D7C423}"/>
               </a:ext>
             </a:extLst>
           </p:cNvPr>
@@ -3588,8 +3588,8 @@
         </p:nvSpPr>
         <p:spPr>
           <a:xfrm>
-            <a:off x="355600" y="2413000"/>
-            <a:ext cx="482600" cy="153888"/>
+            <a:off x="317500" y="2781300"/>
+            <a:ext cx="520700" cy="169277"/>
           </a:xfrm>
           <a:prstGeom prst="rect">
             <a:avLst/>
@@ -3604,7 +3604,7 @@
           <a:p>
             <a:pPr algn="r"/>
             <a:r>
-              <a:rPr lang="de-DE" sz="1000">
+              <a:rPr lang="de-DE" sz="1100">
                 <a:solidFill>
                   <a:srgbClr val="222222"/>
                 </a:solidFill>
@@ -3620,7 +3620,7 @@
           <p:cNvPr id="9" name="Gerader Verbinder 8">
             <a:extLst>
               <a:ext uri="{FF2B5EF4-FFF2-40B4-BE49-F238E27FC236}">
-                <a16:creationId xmlns:a16="http://schemas.microsoft.com/office/drawing/2014/main" id="{2CAF8683-BA68-E970-DB29-4125BB46712D}"/>
+                <a16:creationId xmlns:a16="http://schemas.microsoft.com/office/drawing/2014/main" id="{3FD644F8-5598-4B6D-BD3B-7DE219945198}"/>
               </a:ext>
             </a:extLst>
           </p:cNvPr>
@@ -3629,7 +3629,7 @@
         </p:nvCxnSpPr>
         <p:spPr>
           <a:xfrm>
-            <a:off x="914400" y="1562100"/>
+            <a:off x="914400" y="2133600"/>
             <a:ext cx="5207000" cy="0"/>
           </a:xfrm>
           <a:prstGeom prst="line">
@@ -3643,13 +3643,13 @@
           </a:ln>
         </p:spPr>
         <p:style>
-          <a:lnRef idx="2">
+          <a:lnRef idx="1">
             <a:schemeClr val="accent1"/>
           </a:lnRef>
           <a:fillRef idx="0">
             <a:schemeClr val="accent1"/>
           </a:fillRef>
-          <a:effectRef idx="1">
+          <a:effectRef idx="0">
             <a:schemeClr val="accent1"/>
           </a:effectRef>
           <a:fontRef idx="minor">
@@ -3662,7 +3662,7 @@
           <p:cNvPr id="10" name="Textfeld 9">
             <a:extLst>
               <a:ext uri="{FF2B5EF4-FFF2-40B4-BE49-F238E27FC236}">
-                <a16:creationId xmlns:a16="http://schemas.microsoft.com/office/drawing/2014/main" id="{FC4AD8FA-89FF-A3A7-E6F1-1525C0271485}"/>
+                <a16:creationId xmlns:a16="http://schemas.microsoft.com/office/drawing/2014/main" id="{F41A4E6B-258F-40CF-AC37-B757705815B7}"/>
               </a:ext>
             </a:extLst>
           </p:cNvPr>
@@ -3671,8 +3671,8 @@
         </p:nvSpPr>
         <p:spPr>
           <a:xfrm>
-            <a:off x="355600" y="1460500"/>
-            <a:ext cx="482600" cy="153888"/>
+            <a:off x="317500" y="2019300"/>
+            <a:ext cx="520700" cy="169277"/>
           </a:xfrm>
           <a:prstGeom prst="rect">
             <a:avLst/>
@@ -3687,7 +3687,7 @@
           <a:p>
             <a:pPr algn="r"/>
             <a:r>
-              <a:rPr lang="de-DE" sz="1000">
+              <a:rPr lang="de-DE" sz="1100">
                 <a:solidFill>
                   <a:srgbClr val="222222"/>
                 </a:solidFill>
@@ -3703,7 +3703,7 @@
           <p:cNvPr id="11" name="Gerader Verbinder 10">
             <a:extLst>
               <a:ext uri="{FF2B5EF4-FFF2-40B4-BE49-F238E27FC236}">
-                <a16:creationId xmlns:a16="http://schemas.microsoft.com/office/drawing/2014/main" id="{41F6971A-73B0-6642-F073-4E3A9A3BAD60}"/>
+                <a16:creationId xmlns:a16="http://schemas.microsoft.com/office/drawing/2014/main" id="{6B3B139C-9CE3-47F7-A125-DDAA3C9667D9}"/>
               </a:ext>
             </a:extLst>
           </p:cNvPr>
@@ -3712,7 +3712,7 @@
         </p:nvCxnSpPr>
         <p:spPr>
           <a:xfrm>
-            <a:off x="914400" y="609600"/>
+            <a:off x="914400" y="1371600"/>
             <a:ext cx="5207000" cy="0"/>
           </a:xfrm>
           <a:prstGeom prst="line">
@@ -3726,13 +3726,13 @@
           </a:ln>
         </p:spPr>
         <p:style>
-          <a:lnRef idx="2">
+          <a:lnRef idx="1">
             <a:schemeClr val="accent1"/>
           </a:lnRef>
           <a:fillRef idx="0">
             <a:schemeClr val="accent1"/>
           </a:fillRef>
-          <a:effectRef idx="1">
+          <a:effectRef idx="0">
             <a:schemeClr val="accent1"/>
           </a:effectRef>
           <a:fontRef idx="minor">
@@ -3745,7 +3745,7 @@
           <p:cNvPr id="12" name="Textfeld 11">
             <a:extLst>
               <a:ext uri="{FF2B5EF4-FFF2-40B4-BE49-F238E27FC236}">
-                <a16:creationId xmlns:a16="http://schemas.microsoft.com/office/drawing/2014/main" id="{FDA64176-9623-E06A-478A-CFC237A2C90C}"/>
+                <a16:creationId xmlns:a16="http://schemas.microsoft.com/office/drawing/2014/main" id="{A3A86CDF-65B5-4110-84FB-E9DB92FF819D}"/>
               </a:ext>
             </a:extLst>
           </p:cNvPr>
@@ -3754,8 +3754,8 @@
         </p:nvSpPr>
         <p:spPr>
           <a:xfrm>
-            <a:off x="355600" y="508000"/>
-            <a:ext cx="482600" cy="153888"/>
+            <a:off x="317500" y="1257300"/>
+            <a:ext cx="520700" cy="169277"/>
           </a:xfrm>
           <a:prstGeom prst="rect">
             <a:avLst/>
@@ -3770,7 +3770,7 @@
           <a:p>
             <a:pPr algn="r"/>
             <a:r>
-              <a:rPr lang="de-DE" sz="1000">
+              <a:rPr lang="de-DE" sz="1100">
                 <a:solidFill>
                   <a:srgbClr val="222222"/>
                 </a:solidFill>
@@ -3786,7 +3786,90 @@
           <p:cNvPr id="13" name="Gerader Verbinder 12">
             <a:extLst>
               <a:ext uri="{FF2B5EF4-FFF2-40B4-BE49-F238E27FC236}">
-                <a16:creationId xmlns:a16="http://schemas.microsoft.com/office/drawing/2014/main" id="{D32FF6C1-4661-9BFB-E0A3-A45A7CBF9AF6}"/>
+                <a16:creationId xmlns:a16="http://schemas.microsoft.com/office/drawing/2014/main" id="{30D2C212-396B-4AFB-A07D-7010774F7141}"/>
+              </a:ext>
+            </a:extLst>
+          </p:cNvPr>
+          <p:cNvCxnSpPr/>
+          <p:nvPr/>
+        </p:nvCxnSpPr>
+        <p:spPr>
+          <a:xfrm>
+            <a:off x="914400" y="609600"/>
+            <a:ext cx="5207000" cy="0"/>
+          </a:xfrm>
+          <a:prstGeom prst="line">
+            <a:avLst/>
+          </a:prstGeom>
+          <a:ln w="10160">
+            <a:solidFill>
+              <a:srgbClr val="D5D8DC"/>
+            </a:solidFill>
+            <a:prstDash val="dash"/>
+          </a:ln>
+        </p:spPr>
+        <p:style>
+          <a:lnRef idx="1">
+            <a:schemeClr val="accent1"/>
+          </a:lnRef>
+          <a:fillRef idx="0">
+            <a:schemeClr val="accent1"/>
+          </a:fillRef>
+          <a:effectRef idx="0">
+            <a:schemeClr val="accent1"/>
+          </a:effectRef>
+          <a:fontRef idx="minor">
+            <a:schemeClr val="tx1"/>
+          </a:fontRef>
+        </p:style>
+      </p:cxnSp>
+      <p:sp>
+        <p:nvSpPr>
+          <p:cNvPr id="14" name="Textfeld 13">
+            <a:extLst>
+              <a:ext uri="{FF2B5EF4-FFF2-40B4-BE49-F238E27FC236}">
+                <a16:creationId xmlns:a16="http://schemas.microsoft.com/office/drawing/2014/main" id="{26F4A956-BE34-4CC6-AAB0-02338C2B1200}"/>
+              </a:ext>
+            </a:extLst>
+          </p:cNvPr>
+          <p:cNvSpPr txBox="1"/>
+          <p:nvPr/>
+        </p:nvSpPr>
+        <p:spPr>
+          <a:xfrm>
+            <a:off x="317500" y="495300"/>
+            <a:ext cx="520700" cy="169277"/>
+          </a:xfrm>
+          <a:prstGeom prst="rect">
+            <a:avLst/>
+          </a:prstGeom>
+          <a:noFill/>
+        </p:spPr>
+        <p:txBody>
+          <a:bodyPr vert="horz" wrap="square" lIns="0" tIns="0" rIns="0" bIns="0" rtlCol="0">
+            <a:spAutoFit/>
+          </a:bodyPr>
+          <a:lstStyle/>
+          <a:p>
+            <a:pPr algn="r"/>
+            <a:r>
+              <a:rPr lang="de-DE" sz="1100">
+                <a:solidFill>
+                  <a:srgbClr val="222222"/>
+                </a:solidFill>
+                <a:latin typeface="Arial" panose="020B0604020202020204" pitchFamily="34" charset="0"/>
+              </a:rPr>
+              <a:t>0.025</a:t>
+            </a:r>
+          </a:p>
+        </p:txBody>
+      </p:sp>
+      <p:cxnSp>
+        <p:nvCxnSpPr>
+          <p:cNvPr id="15" name="Gerader Verbinder 14">
+            <a:extLst>
+              <a:ext uri="{FF2B5EF4-FFF2-40B4-BE49-F238E27FC236}">
+                <a16:creationId xmlns:a16="http://schemas.microsoft.com/office/drawing/2014/main" id="{746642F0-974D-4D35-88A2-90E01DC4A120}"/>
               </a:ext>
             </a:extLst>
           </p:cNvPr>
@@ -3808,13 +3891,13 @@
           </a:ln>
         </p:spPr>
         <p:style>
-          <a:lnRef idx="2">
+          <a:lnRef idx="1">
             <a:schemeClr val="accent1"/>
           </a:lnRef>
           <a:fillRef idx="0">
             <a:schemeClr val="accent1"/>
           </a:fillRef>
-          <a:effectRef idx="1">
+          <a:effectRef idx="0">
             <a:schemeClr val="accent1"/>
           </a:effectRef>
           <a:fontRef idx="minor">
@@ -3824,10 +3907,10 @@
       </p:cxnSp>
       <p:cxnSp>
         <p:nvCxnSpPr>
-          <p:cNvPr id="14" name="Gerader Verbinder 13">
-            <a:extLst>
-              <a:ext uri="{FF2B5EF4-FFF2-40B4-BE49-F238E27FC236}">
-                <a16:creationId xmlns:a16="http://schemas.microsoft.com/office/drawing/2014/main" id="{A6512DAB-E79C-2838-FD8C-CCC59B058FB7}"/>
+          <p:cNvPr id="16" name="Gerader Verbinder 15">
+            <a:extLst>
+              <a:ext uri="{FF2B5EF4-FFF2-40B4-BE49-F238E27FC236}">
+                <a16:creationId xmlns:a16="http://schemas.microsoft.com/office/drawing/2014/main" id="{0DA8E8ED-AD5B-4BA2-8D7E-2C115335C82F}"/>
               </a:ext>
             </a:extLst>
           </p:cNvPr>
@@ -3849,13 +3932,13 @@
           </a:ln>
         </p:spPr>
         <p:style>
-          <a:lnRef idx="2">
+          <a:lnRef idx="1">
             <a:schemeClr val="accent1"/>
           </a:lnRef>
           <a:fillRef idx="0">
             <a:schemeClr val="accent1"/>
           </a:fillRef>
-          <a:effectRef idx="1">
+          <a:effectRef idx="0">
             <a:schemeClr val="accent1"/>
           </a:effectRef>
           <a:fontRef idx="minor">
@@ -3865,10 +3948,10 @@
       </p:cxnSp>
       <p:sp>
         <p:nvSpPr>
-          <p:cNvPr id="15" name="Rechteck 14">
-            <a:extLst>
-              <a:ext uri="{FF2B5EF4-FFF2-40B4-BE49-F238E27FC236}">
-                <a16:creationId xmlns:a16="http://schemas.microsoft.com/office/drawing/2014/main" id="{4887C0DB-2728-469F-72ED-2D1AB18E0C8B}"/>
+          <p:cNvPr id="17" name="Rechteck 16">
+            <a:extLst>
+              <a:ext uri="{FF2B5EF4-FFF2-40B4-BE49-F238E27FC236}">
+                <a16:creationId xmlns:a16="http://schemas.microsoft.com/office/drawing/2014/main" id="{579CEAAF-F4F8-48F6-A876-6AAD85F6A69A}"/>
               </a:ext>
             </a:extLst>
           </p:cNvPr>
@@ -3877,8 +3960,8 @@
         </p:nvSpPr>
         <p:spPr>
           <a:xfrm>
-            <a:off x="1308100" y="1750505"/>
-            <a:ext cx="292100" cy="2669095"/>
+            <a:off x="1308100" y="1797251"/>
+            <a:ext cx="292100" cy="2622349"/>
           </a:xfrm>
           <a:prstGeom prst="rect">
             <a:avLst/>
@@ -3897,7 +3980,7 @@
         <p:style>
           <a:lnRef idx="2">
             <a:schemeClr val="accent1">
-              <a:shade val="15000"/>
+              <a:shade val="50000"/>
             </a:schemeClr>
           </a:lnRef>
           <a:fillRef idx="1">
@@ -3921,10 +4004,10 @@
       </p:sp>
       <p:sp>
         <p:nvSpPr>
-          <p:cNvPr id="16" name="Rechteck 15">
-            <a:extLst>
-              <a:ext uri="{FF2B5EF4-FFF2-40B4-BE49-F238E27FC236}">
-                <a16:creationId xmlns:a16="http://schemas.microsoft.com/office/drawing/2014/main" id="{453F0BE1-0641-3F9A-70E9-C681E9865229}"/>
+          <p:cNvPr id="18" name="Rechteck 17">
+            <a:extLst>
+              <a:ext uri="{FF2B5EF4-FFF2-40B4-BE49-F238E27FC236}">
+                <a16:creationId xmlns:a16="http://schemas.microsoft.com/office/drawing/2014/main" id="{9223A78F-A84E-4B00-B1AB-D7CF0CF4BE37}"/>
               </a:ext>
             </a:extLst>
           </p:cNvPr>
@@ -3933,8 +4016,8 @@
         </p:nvSpPr>
         <p:spPr>
           <a:xfrm>
-            <a:off x="1701800" y="1012507"/>
-            <a:ext cx="292100" cy="3407093"/>
+            <a:off x="1701800" y="1006419"/>
+            <a:ext cx="292100" cy="3413181"/>
           </a:xfrm>
           <a:prstGeom prst="rect">
             <a:avLst/>
@@ -3953,7 +4036,7 @@
         <p:style>
           <a:lnRef idx="2">
             <a:schemeClr val="accent1">
-              <a:shade val="15000"/>
+              <a:shade val="50000"/>
             </a:schemeClr>
           </a:lnRef>
           <a:fillRef idx="1">
@@ -3977,10 +4060,10 @@
       </p:sp>
       <p:sp>
         <p:nvSpPr>
-          <p:cNvPr id="17" name="Textfeld 16">
-            <a:extLst>
-              <a:ext uri="{FF2B5EF4-FFF2-40B4-BE49-F238E27FC236}">
-                <a16:creationId xmlns:a16="http://schemas.microsoft.com/office/drawing/2014/main" id="{E809FD78-F190-74EC-76F3-A68173D3F7A4}"/>
+          <p:cNvPr id="19" name="Textfeld 18">
+            <a:extLst>
+              <a:ext uri="{FF2B5EF4-FFF2-40B4-BE49-F238E27FC236}">
+                <a16:creationId xmlns:a16="http://schemas.microsoft.com/office/drawing/2014/main" id="{B055125C-3144-4D08-994D-5FBDDF58E679}"/>
               </a:ext>
             </a:extLst>
           </p:cNvPr>
@@ -3989,8 +4072,8 @@
         </p:nvSpPr>
         <p:spPr>
           <a:xfrm>
-            <a:off x="1155700" y="1521904"/>
-            <a:ext cx="609600" cy="138499"/>
+            <a:off x="1117600" y="1555951"/>
+            <a:ext cx="685800" cy="153888"/>
           </a:xfrm>
           <a:prstGeom prst="rect">
             <a:avLst/>
@@ -4005,23 +4088,23 @@
           <a:p>
             <a:pPr algn="ctr"/>
             <a:r>
-              <a:rPr lang="de-DE" sz="900">
+              <a:rPr lang="de-DE" sz="1000">
                 <a:solidFill>
                   <a:srgbClr val="222222"/>
                 </a:solidFill>
                 <a:latin typeface="Arial" panose="020B0604020202020204" pitchFamily="34" charset="0"/>
               </a:rPr>
-              <a:t>0.0140</a:t>
-            </a:r>
-          </a:p>
-        </p:txBody>
-      </p:sp>
-      <p:sp>
-        <p:nvSpPr>
-          <p:cNvPr id="18" name="Textfeld 17">
-            <a:extLst>
-              <a:ext uri="{FF2B5EF4-FFF2-40B4-BE49-F238E27FC236}">
-                <a16:creationId xmlns:a16="http://schemas.microsoft.com/office/drawing/2014/main" id="{2DBAE0ED-5D12-8016-42B5-3705013ABFAC}"/>
+              <a:t>0.0172</a:t>
+            </a:r>
+          </a:p>
+        </p:txBody>
+      </p:sp>
+      <p:sp>
+        <p:nvSpPr>
+          <p:cNvPr id="20" name="Textfeld 19">
+            <a:extLst>
+              <a:ext uri="{FF2B5EF4-FFF2-40B4-BE49-F238E27FC236}">
+                <a16:creationId xmlns:a16="http://schemas.microsoft.com/office/drawing/2014/main" id="{21AF2197-7AEE-44BA-A284-2BB791AF4B51}"/>
               </a:ext>
             </a:extLst>
           </p:cNvPr>
@@ -4030,8 +4113,8 @@
         </p:nvSpPr>
         <p:spPr>
           <a:xfrm>
-            <a:off x="1549400" y="783907"/>
-            <a:ext cx="609600" cy="138499"/>
+            <a:off x="1511300" y="765119"/>
+            <a:ext cx="685800" cy="153888"/>
           </a:xfrm>
           <a:prstGeom prst="rect">
             <a:avLst/>
@@ -4046,23 +4129,23 @@
           <a:p>
             <a:pPr algn="ctr"/>
             <a:r>
-              <a:rPr lang="de-DE" sz="900">
+              <a:rPr lang="de-DE" sz="1000">
                 <a:solidFill>
                   <a:srgbClr val="222222"/>
                 </a:solidFill>
                 <a:latin typeface="Arial" panose="020B0604020202020204" pitchFamily="34" charset="0"/>
               </a:rPr>
-              <a:t>0.0179</a:t>
-            </a:r>
-          </a:p>
-        </p:txBody>
-      </p:sp>
-      <p:sp>
-        <p:nvSpPr>
-          <p:cNvPr id="19" name="Textfeld 18">
-            <a:extLst>
-              <a:ext uri="{FF2B5EF4-FFF2-40B4-BE49-F238E27FC236}">
-                <a16:creationId xmlns:a16="http://schemas.microsoft.com/office/drawing/2014/main" id="{B27FE6C1-D546-2164-35B1-0FC006BAFD77}"/>
+              <a:t>0.0224</a:t>
+            </a:r>
+          </a:p>
+        </p:txBody>
+      </p:sp>
+      <p:sp>
+        <p:nvSpPr>
+          <p:cNvPr id="21" name="Textfeld 20">
+            <a:extLst>
+              <a:ext uri="{FF2B5EF4-FFF2-40B4-BE49-F238E27FC236}">
+                <a16:creationId xmlns:a16="http://schemas.microsoft.com/office/drawing/2014/main" id="{01AF7A7C-7A7E-4A87-80D0-63D21F68E222}"/>
               </a:ext>
             </a:extLst>
           </p:cNvPr>
@@ -4072,7 +4155,7 @@
         <p:spPr>
           <a:xfrm>
             <a:off x="1219200" y="4495800"/>
-            <a:ext cx="863600" cy="184666"/>
+            <a:ext cx="863600" cy="200055"/>
           </a:xfrm>
           <a:prstGeom prst="rect">
             <a:avLst/>
@@ -4087,7 +4170,7 @@
           <a:p>
             <a:pPr algn="ctr"/>
             <a:r>
-              <a:rPr lang="de-DE" sz="1200" b="1">
+              <a:rPr lang="de-DE" sz="1300" b="1">
                 <a:solidFill>
                   <a:srgbClr val="222222"/>
                 </a:solidFill>
@@ -4100,10 +4183,10 @@
       </p:sp>
       <p:sp>
         <p:nvSpPr>
-          <p:cNvPr id="20" name="Rechteck 19">
-            <a:extLst>
-              <a:ext uri="{FF2B5EF4-FFF2-40B4-BE49-F238E27FC236}">
-                <a16:creationId xmlns:a16="http://schemas.microsoft.com/office/drawing/2014/main" id="{A60746ED-DB07-BF67-60A1-54453BED4624}"/>
+          <p:cNvPr id="22" name="Rechteck 21">
+            <a:extLst>
+              <a:ext uri="{FF2B5EF4-FFF2-40B4-BE49-F238E27FC236}">
+                <a16:creationId xmlns:a16="http://schemas.microsoft.com/office/drawing/2014/main" id="{ECB7765D-D731-4AA1-8370-B1B124E866FD}"/>
               </a:ext>
             </a:extLst>
           </p:cNvPr>
@@ -4112,8 +4195,8 @@
         </p:nvSpPr>
         <p:spPr>
           <a:xfrm>
-            <a:off x="2514600" y="2061782"/>
-            <a:ext cx="292100" cy="2357818"/>
+            <a:off x="2514600" y="2196481"/>
+            <a:ext cx="292100" cy="2223119"/>
           </a:xfrm>
           <a:prstGeom prst="rect">
             <a:avLst/>
@@ -4132,7 +4215,7 @@
         <p:style>
           <a:lnRef idx="2">
             <a:schemeClr val="accent1">
-              <a:shade val="15000"/>
+              <a:shade val="50000"/>
             </a:schemeClr>
           </a:lnRef>
           <a:fillRef idx="1">
@@ -4156,10 +4239,10 @@
       </p:sp>
       <p:sp>
         <p:nvSpPr>
-          <p:cNvPr id="21" name="Rechteck 20">
-            <a:extLst>
-              <a:ext uri="{FF2B5EF4-FFF2-40B4-BE49-F238E27FC236}">
-                <a16:creationId xmlns:a16="http://schemas.microsoft.com/office/drawing/2014/main" id="{3830DC9C-3F04-8FB2-C4A4-50EF3DB54B31}"/>
+          <p:cNvPr id="23" name="Rechteck 22">
+            <a:extLst>
+              <a:ext uri="{FF2B5EF4-FFF2-40B4-BE49-F238E27FC236}">
+                <a16:creationId xmlns:a16="http://schemas.microsoft.com/office/drawing/2014/main" id="{FE505F91-045D-42EB-B087-5C15F8CBF8FF}"/>
               </a:ext>
             </a:extLst>
           </p:cNvPr>
@@ -4168,8 +4251,8 @@
         </p:nvSpPr>
         <p:spPr>
           <a:xfrm>
-            <a:off x="2908300" y="1514856"/>
-            <a:ext cx="292100" cy="2904744"/>
+            <a:off x="2908300" y="1680369"/>
+            <a:ext cx="292100" cy="2739231"/>
           </a:xfrm>
           <a:prstGeom prst="rect">
             <a:avLst/>
@@ -4188,7 +4271,7 @@
         <p:style>
           <a:lnRef idx="2">
             <a:schemeClr val="accent1">
-              <a:shade val="15000"/>
+              <a:shade val="50000"/>
             </a:schemeClr>
           </a:lnRef>
           <a:fillRef idx="1">
@@ -4212,10 +4295,10 @@
       </p:sp>
       <p:sp>
         <p:nvSpPr>
-          <p:cNvPr id="22" name="Textfeld 21">
-            <a:extLst>
-              <a:ext uri="{FF2B5EF4-FFF2-40B4-BE49-F238E27FC236}">
-                <a16:creationId xmlns:a16="http://schemas.microsoft.com/office/drawing/2014/main" id="{289B21D4-F900-735C-CBAD-7DE4518AFA06}"/>
+          <p:cNvPr id="24" name="Textfeld 23">
+            <a:extLst>
+              <a:ext uri="{FF2B5EF4-FFF2-40B4-BE49-F238E27FC236}">
+                <a16:creationId xmlns:a16="http://schemas.microsoft.com/office/drawing/2014/main" id="{E6406625-25A7-4306-B0AE-680F6107C5C5}"/>
               </a:ext>
             </a:extLst>
           </p:cNvPr>
@@ -4224,8 +4307,8 @@
         </p:nvSpPr>
         <p:spPr>
           <a:xfrm>
-            <a:off x="2362200" y="1833182"/>
-            <a:ext cx="609600" cy="138499"/>
+            <a:off x="2324100" y="1955181"/>
+            <a:ext cx="685800" cy="153888"/>
           </a:xfrm>
           <a:prstGeom prst="rect">
             <a:avLst/>
@@ -4240,23 +4323,23 @@
           <a:p>
             <a:pPr algn="ctr"/>
             <a:r>
-              <a:rPr lang="de-DE" sz="900">
+              <a:rPr lang="de-DE" sz="1000">
                 <a:solidFill>
                   <a:srgbClr val="222222"/>
                 </a:solidFill>
                 <a:latin typeface="Arial" panose="020B0604020202020204" pitchFamily="34" charset="0"/>
               </a:rPr>
-              <a:t>0.0124</a:t>
-            </a:r>
-          </a:p>
-        </p:txBody>
-      </p:sp>
-      <p:sp>
-        <p:nvSpPr>
-          <p:cNvPr id="23" name="Textfeld 22">
-            <a:extLst>
-              <a:ext uri="{FF2B5EF4-FFF2-40B4-BE49-F238E27FC236}">
-                <a16:creationId xmlns:a16="http://schemas.microsoft.com/office/drawing/2014/main" id="{6B31FAF7-5D4D-56B4-E939-A792D42A3929}"/>
+              <a:t>0.0146</a:t>
+            </a:r>
+          </a:p>
+        </p:txBody>
+      </p:sp>
+      <p:sp>
+        <p:nvSpPr>
+          <p:cNvPr id="25" name="Textfeld 24">
+            <a:extLst>
+              <a:ext uri="{FF2B5EF4-FFF2-40B4-BE49-F238E27FC236}">
+                <a16:creationId xmlns:a16="http://schemas.microsoft.com/office/drawing/2014/main" id="{B1B76C7F-7B68-4F18-B91C-E784207FDEBD}"/>
               </a:ext>
             </a:extLst>
           </p:cNvPr>
@@ -4265,8 +4348,8 @@
         </p:nvSpPr>
         <p:spPr>
           <a:xfrm>
-            <a:off x="2755900" y="1286256"/>
-            <a:ext cx="609600" cy="138499"/>
+            <a:off x="2717800" y="1439069"/>
+            <a:ext cx="685800" cy="153888"/>
           </a:xfrm>
           <a:prstGeom prst="rect">
             <a:avLst/>
@@ -4281,23 +4364,23 @@
           <a:p>
             <a:pPr algn="ctr"/>
             <a:r>
-              <a:rPr lang="de-DE" sz="900">
+              <a:rPr lang="de-DE" sz="1000">
                 <a:solidFill>
                   <a:srgbClr val="222222"/>
                 </a:solidFill>
                 <a:latin typeface="Arial" panose="020B0604020202020204" pitchFamily="34" charset="0"/>
               </a:rPr>
-              <a:t>0.0152</a:t>
-            </a:r>
-          </a:p>
-        </p:txBody>
-      </p:sp>
-      <p:sp>
-        <p:nvSpPr>
-          <p:cNvPr id="24" name="Textfeld 23">
-            <a:extLst>
-              <a:ext uri="{FF2B5EF4-FFF2-40B4-BE49-F238E27FC236}">
-                <a16:creationId xmlns:a16="http://schemas.microsoft.com/office/drawing/2014/main" id="{66016037-B745-3B89-38AD-9C58F2102E2C}"/>
+              <a:t>0.0180</a:t>
+            </a:r>
+          </a:p>
+        </p:txBody>
+      </p:sp>
+      <p:sp>
+        <p:nvSpPr>
+          <p:cNvPr id="26" name="Textfeld 25">
+            <a:extLst>
+              <a:ext uri="{FF2B5EF4-FFF2-40B4-BE49-F238E27FC236}">
+                <a16:creationId xmlns:a16="http://schemas.microsoft.com/office/drawing/2014/main" id="{2F6C122D-5C3E-49A6-B185-124D964BBD5D}"/>
               </a:ext>
             </a:extLst>
           </p:cNvPr>
@@ -4307,7 +4390,7 @@
         <p:spPr>
           <a:xfrm>
             <a:off x="2425700" y="4495800"/>
-            <a:ext cx="863600" cy="184666"/>
+            <a:ext cx="863600" cy="200055"/>
           </a:xfrm>
           <a:prstGeom prst="rect">
             <a:avLst/>
@@ -4322,7 +4405,7 @@
           <a:p>
             <a:pPr algn="ctr"/>
             <a:r>
-              <a:rPr lang="de-DE" sz="1200" b="1">
+              <a:rPr lang="de-DE" sz="1300" b="1">
                 <a:solidFill>
                   <a:srgbClr val="222222"/>
                 </a:solidFill>
@@ -4335,10 +4418,10 @@
       </p:sp>
       <p:sp>
         <p:nvSpPr>
-          <p:cNvPr id="25" name="Rechteck 24">
-            <a:extLst>
-              <a:ext uri="{FF2B5EF4-FFF2-40B4-BE49-F238E27FC236}">
-                <a16:creationId xmlns:a16="http://schemas.microsoft.com/office/drawing/2014/main" id="{A1DA77F2-ECF2-7292-4C2F-F92BD3CA86D0}"/>
+          <p:cNvPr id="27" name="Rechteck 26">
+            <a:extLst>
+              <a:ext uri="{FF2B5EF4-FFF2-40B4-BE49-F238E27FC236}">
+                <a16:creationId xmlns:a16="http://schemas.microsoft.com/office/drawing/2014/main" id="{3E9119E8-242D-40FA-8B95-049E21D0D13C}"/>
               </a:ext>
             </a:extLst>
           </p:cNvPr>
@@ -4347,8 +4430,8 @@
         </p:nvSpPr>
         <p:spPr>
           <a:xfrm>
-            <a:off x="3721100" y="1709547"/>
-            <a:ext cx="292100" cy="2710053"/>
+            <a:off x="3721100" y="1879989"/>
+            <a:ext cx="292100" cy="2539611"/>
           </a:xfrm>
           <a:prstGeom prst="rect">
             <a:avLst/>
@@ -4367,7 +4450,7 @@
         <p:style>
           <a:lnRef idx="2">
             <a:schemeClr val="accent1">
-              <a:shade val="15000"/>
+              <a:shade val="50000"/>
             </a:schemeClr>
           </a:lnRef>
           <a:fillRef idx="1">
@@ -4391,10 +4474,10 @@
       </p:sp>
       <p:sp>
         <p:nvSpPr>
-          <p:cNvPr id="26" name="Rechteck 25">
-            <a:extLst>
-              <a:ext uri="{FF2B5EF4-FFF2-40B4-BE49-F238E27FC236}">
-                <a16:creationId xmlns:a16="http://schemas.microsoft.com/office/drawing/2014/main" id="{1700CB96-0ED0-0095-50A2-8C7AEB11BCC4}"/>
+          <p:cNvPr id="28" name="Rechteck 27">
+            <a:extLst>
+              <a:ext uri="{FF2B5EF4-FFF2-40B4-BE49-F238E27FC236}">
+                <a16:creationId xmlns:a16="http://schemas.microsoft.com/office/drawing/2014/main" id="{CCAA7507-A33D-4E08-83F3-D72E328D2F17}"/>
               </a:ext>
             </a:extLst>
           </p:cNvPr>
@@ -4403,8 +4486,8 @@
         </p:nvSpPr>
         <p:spPr>
           <a:xfrm>
-            <a:off x="4114800" y="1156526"/>
-            <a:ext cx="292100" cy="3263074"/>
+            <a:off x="4114800" y="1381086"/>
+            <a:ext cx="292100" cy="3038514"/>
           </a:xfrm>
           <a:prstGeom prst="rect">
             <a:avLst/>
@@ -4423,7 +4506,7 @@
         <p:style>
           <a:lnRef idx="2">
             <a:schemeClr val="accent1">
-              <a:shade val="15000"/>
+              <a:shade val="50000"/>
             </a:schemeClr>
           </a:lnRef>
           <a:fillRef idx="1">
@@ -4447,10 +4530,10 @@
       </p:sp>
       <p:sp>
         <p:nvSpPr>
-          <p:cNvPr id="27" name="Textfeld 26">
-            <a:extLst>
-              <a:ext uri="{FF2B5EF4-FFF2-40B4-BE49-F238E27FC236}">
-                <a16:creationId xmlns:a16="http://schemas.microsoft.com/office/drawing/2014/main" id="{4D96DDDC-08CE-A006-3C4B-9242CBACEF54}"/>
+          <p:cNvPr id="29" name="Textfeld 28">
+            <a:extLst>
+              <a:ext uri="{FF2B5EF4-FFF2-40B4-BE49-F238E27FC236}">
+                <a16:creationId xmlns:a16="http://schemas.microsoft.com/office/drawing/2014/main" id="{028CD3DF-389C-4CA6-AE0A-4DB905061EA0}"/>
               </a:ext>
             </a:extLst>
           </p:cNvPr>
@@ -4459,8 +4542,8 @@
         </p:nvSpPr>
         <p:spPr>
           <a:xfrm>
-            <a:off x="3568700" y="1480947"/>
-            <a:ext cx="609600" cy="138499"/>
+            <a:off x="3530600" y="1638689"/>
+            <a:ext cx="685800" cy="153888"/>
           </a:xfrm>
           <a:prstGeom prst="rect">
             <a:avLst/>
@@ -4475,23 +4558,23 @@
           <a:p>
             <a:pPr algn="ctr"/>
             <a:r>
-              <a:rPr lang="de-DE" sz="900">
+              <a:rPr lang="de-DE" sz="1000">
                 <a:solidFill>
                   <a:srgbClr val="222222"/>
                 </a:solidFill>
                 <a:latin typeface="Arial" panose="020B0604020202020204" pitchFamily="34" charset="0"/>
               </a:rPr>
-              <a:t>0.0142</a:t>
-            </a:r>
-          </a:p>
-        </p:txBody>
-      </p:sp>
-      <p:sp>
-        <p:nvSpPr>
-          <p:cNvPr id="28" name="Textfeld 27">
-            <a:extLst>
-              <a:ext uri="{FF2B5EF4-FFF2-40B4-BE49-F238E27FC236}">
-                <a16:creationId xmlns:a16="http://schemas.microsoft.com/office/drawing/2014/main" id="{35080156-970D-D162-63CE-8D7DDFB3E903}"/>
+              <a:t>0.0167</a:t>
+            </a:r>
+          </a:p>
+        </p:txBody>
+      </p:sp>
+      <p:sp>
+        <p:nvSpPr>
+          <p:cNvPr id="30" name="Textfeld 29">
+            <a:extLst>
+              <a:ext uri="{FF2B5EF4-FFF2-40B4-BE49-F238E27FC236}">
+                <a16:creationId xmlns:a16="http://schemas.microsoft.com/office/drawing/2014/main" id="{BE4CF771-0AD6-43A0-8015-60C8EEDC87E3}"/>
               </a:ext>
             </a:extLst>
           </p:cNvPr>
@@ -4500,8 +4583,8 @@
         </p:nvSpPr>
         <p:spPr>
           <a:xfrm>
-            <a:off x="3962400" y="927926"/>
-            <a:ext cx="609600" cy="138499"/>
+            <a:off x="3924300" y="1139786"/>
+            <a:ext cx="685800" cy="153888"/>
           </a:xfrm>
           <a:prstGeom prst="rect">
             <a:avLst/>
@@ -4516,23 +4599,23 @@
           <a:p>
             <a:pPr algn="ctr"/>
             <a:r>
-              <a:rPr lang="de-DE" sz="900">
+              <a:rPr lang="de-DE" sz="1000">
                 <a:solidFill>
                   <a:srgbClr val="222222"/>
                 </a:solidFill>
                 <a:latin typeface="Arial" panose="020B0604020202020204" pitchFamily="34" charset="0"/>
               </a:rPr>
-              <a:t>0.0171</a:t>
-            </a:r>
-          </a:p>
-        </p:txBody>
-      </p:sp>
-      <p:sp>
-        <p:nvSpPr>
-          <p:cNvPr id="29" name="Textfeld 28">
-            <a:extLst>
-              <a:ext uri="{FF2B5EF4-FFF2-40B4-BE49-F238E27FC236}">
-                <a16:creationId xmlns:a16="http://schemas.microsoft.com/office/drawing/2014/main" id="{D9B2AFB6-EEF9-438D-8333-AC5A3D872A12}"/>
+              <a:t>0.0199</a:t>
+            </a:r>
+          </a:p>
+        </p:txBody>
+      </p:sp>
+      <p:sp>
+        <p:nvSpPr>
+          <p:cNvPr id="31" name="Textfeld 30">
+            <a:extLst>
+              <a:ext uri="{FF2B5EF4-FFF2-40B4-BE49-F238E27FC236}">
+                <a16:creationId xmlns:a16="http://schemas.microsoft.com/office/drawing/2014/main" id="{FC36864F-0538-44AA-B50D-8DDE08396F11}"/>
               </a:ext>
             </a:extLst>
           </p:cNvPr>
@@ -4542,7 +4625,7 @@
         <p:spPr>
           <a:xfrm>
             <a:off x="3632200" y="4495800"/>
-            <a:ext cx="863600" cy="184666"/>
+            <a:ext cx="863600" cy="200055"/>
           </a:xfrm>
           <a:prstGeom prst="rect">
             <a:avLst/>
@@ -4557,7 +4640,7 @@
           <a:p>
             <a:pPr algn="ctr"/>
             <a:r>
-              <a:rPr lang="de-DE" sz="1200" b="1">
+              <a:rPr lang="de-DE" sz="1300" b="1">
                 <a:solidFill>
                   <a:srgbClr val="222222"/>
                 </a:solidFill>
@@ -4570,10 +4653,10 @@
       </p:sp>
       <p:sp>
         <p:nvSpPr>
-          <p:cNvPr id="30" name="Rechteck 29">
-            <a:extLst>
-              <a:ext uri="{FF2B5EF4-FFF2-40B4-BE49-F238E27FC236}">
-                <a16:creationId xmlns:a16="http://schemas.microsoft.com/office/drawing/2014/main" id="{6F759737-47F8-B70D-2399-52F254C2BB64}"/>
+          <p:cNvPr id="32" name="Rechteck 31">
+            <a:extLst>
+              <a:ext uri="{FF2B5EF4-FFF2-40B4-BE49-F238E27FC236}">
+                <a16:creationId xmlns:a16="http://schemas.microsoft.com/office/drawing/2014/main" id="{4AAB417F-78E2-4C9F-9112-BD6188730B67}"/>
               </a:ext>
             </a:extLst>
           </p:cNvPr>
@@ -4582,8 +4665,8 @@
         </p:nvSpPr>
         <p:spPr>
           <a:xfrm>
-            <a:off x="4927600" y="2114169"/>
-            <a:ext cx="292100" cy="2305431"/>
+            <a:off x="4927600" y="2104696"/>
+            <a:ext cx="292100" cy="2314904"/>
           </a:xfrm>
           <a:prstGeom prst="rect">
             <a:avLst/>
@@ -4602,7 +4685,7 @@
         <p:style>
           <a:lnRef idx="2">
             <a:schemeClr val="accent1">
-              <a:shade val="15000"/>
+              <a:shade val="50000"/>
             </a:schemeClr>
           </a:lnRef>
           <a:fillRef idx="1">
@@ -4626,10 +4709,10 @@
       </p:sp>
       <p:sp>
         <p:nvSpPr>
-          <p:cNvPr id="31" name="Rechteck 30">
-            <a:extLst>
-              <a:ext uri="{FF2B5EF4-FFF2-40B4-BE49-F238E27FC236}">
-                <a16:creationId xmlns:a16="http://schemas.microsoft.com/office/drawing/2014/main" id="{A47D8630-ECB9-344A-3289-11950BB4D3BB}"/>
+          <p:cNvPr id="33" name="Rechteck 32">
+            <a:extLst>
+              <a:ext uri="{FF2B5EF4-FFF2-40B4-BE49-F238E27FC236}">
+                <a16:creationId xmlns:a16="http://schemas.microsoft.com/office/drawing/2014/main" id="{1338538D-14F7-4250-8BC1-750DD34043A2}"/>
               </a:ext>
             </a:extLst>
           </p:cNvPr>
@@ -4638,8 +4721,8 @@
         </p:nvSpPr>
         <p:spPr>
           <a:xfrm>
-            <a:off x="5321300" y="1442847"/>
-            <a:ext cx="292100" cy="2976753"/>
+            <a:off x="5321300" y="1433852"/>
+            <a:ext cx="292100" cy="2985748"/>
           </a:xfrm>
           <a:prstGeom prst="rect">
             <a:avLst/>
@@ -4658,7 +4741,7 @@
         <p:style>
           <a:lnRef idx="2">
             <a:schemeClr val="accent1">
-              <a:shade val="15000"/>
+              <a:shade val="50000"/>
             </a:schemeClr>
           </a:lnRef>
           <a:fillRef idx="1">
@@ -4682,10 +4765,10 @@
       </p:sp>
       <p:sp>
         <p:nvSpPr>
-          <p:cNvPr id="32" name="Textfeld 31">
-            <a:extLst>
-              <a:ext uri="{FF2B5EF4-FFF2-40B4-BE49-F238E27FC236}">
-                <a16:creationId xmlns:a16="http://schemas.microsoft.com/office/drawing/2014/main" id="{DBFDE3E4-6FF4-F883-BABB-99738EBC477F}"/>
+          <p:cNvPr id="34" name="Textfeld 33">
+            <a:extLst>
+              <a:ext uri="{FF2B5EF4-FFF2-40B4-BE49-F238E27FC236}">
+                <a16:creationId xmlns:a16="http://schemas.microsoft.com/office/drawing/2014/main" id="{A9F82F1D-F9FD-4C08-9ABD-4EEBE20752A9}"/>
               </a:ext>
             </a:extLst>
           </p:cNvPr>
@@ -4694,8 +4777,8 @@
         </p:nvSpPr>
         <p:spPr>
           <a:xfrm>
-            <a:off x="4775200" y="1885569"/>
-            <a:ext cx="609600" cy="138499"/>
+            <a:off x="4737100" y="1863396"/>
+            <a:ext cx="685800" cy="153888"/>
           </a:xfrm>
           <a:prstGeom prst="rect">
             <a:avLst/>
@@ -4710,23 +4793,23 @@
           <a:p>
             <a:pPr algn="ctr"/>
             <a:r>
-              <a:rPr lang="de-DE" sz="900">
+              <a:rPr lang="de-DE" sz="1000">
                 <a:solidFill>
                   <a:srgbClr val="222222"/>
                 </a:solidFill>
                 <a:latin typeface="Arial" panose="020B0604020202020204" pitchFamily="34" charset="0"/>
               </a:rPr>
-              <a:t>0.0121</a:t>
-            </a:r>
-          </a:p>
-        </p:txBody>
-      </p:sp>
-      <p:sp>
-        <p:nvSpPr>
-          <p:cNvPr id="33" name="Textfeld 32">
-            <a:extLst>
-              <a:ext uri="{FF2B5EF4-FFF2-40B4-BE49-F238E27FC236}">
-                <a16:creationId xmlns:a16="http://schemas.microsoft.com/office/drawing/2014/main" id="{7BE4E47F-9851-9BB0-3F3F-0C435BFB8279}"/>
+              <a:t>0.0152</a:t>
+            </a:r>
+          </a:p>
+        </p:txBody>
+      </p:sp>
+      <p:sp>
+        <p:nvSpPr>
+          <p:cNvPr id="35" name="Textfeld 34">
+            <a:extLst>
+              <a:ext uri="{FF2B5EF4-FFF2-40B4-BE49-F238E27FC236}">
+                <a16:creationId xmlns:a16="http://schemas.microsoft.com/office/drawing/2014/main" id="{EB88825B-116E-4B58-9724-1AD98F6ADB9D}"/>
               </a:ext>
             </a:extLst>
           </p:cNvPr>
@@ -4735,8 +4818,8 @@
         </p:nvSpPr>
         <p:spPr>
           <a:xfrm>
-            <a:off x="5168900" y="1214247"/>
-            <a:ext cx="609600" cy="138499"/>
+            <a:off x="5130800" y="1192552"/>
+            <a:ext cx="685800" cy="153888"/>
           </a:xfrm>
           <a:prstGeom prst="rect">
             <a:avLst/>
@@ -4751,23 +4834,23 @@
           <a:p>
             <a:pPr algn="ctr"/>
             <a:r>
-              <a:rPr lang="de-DE" sz="900">
+              <a:rPr lang="de-DE" sz="1000">
                 <a:solidFill>
                   <a:srgbClr val="222222"/>
                 </a:solidFill>
                 <a:latin typeface="Arial" panose="020B0604020202020204" pitchFamily="34" charset="0"/>
               </a:rPr>
-              <a:t>0.0156</a:t>
-            </a:r>
-          </a:p>
-        </p:txBody>
-      </p:sp>
-      <p:sp>
-        <p:nvSpPr>
-          <p:cNvPr id="34" name="Textfeld 33">
-            <a:extLst>
-              <a:ext uri="{FF2B5EF4-FFF2-40B4-BE49-F238E27FC236}">
-                <a16:creationId xmlns:a16="http://schemas.microsoft.com/office/drawing/2014/main" id="{B5122898-70EC-44B2-DA00-567BCE72804E}"/>
+              <a:t>0.0196</a:t>
+            </a:r>
+          </a:p>
+        </p:txBody>
+      </p:sp>
+      <p:sp>
+        <p:nvSpPr>
+          <p:cNvPr id="36" name="Textfeld 35">
+            <a:extLst>
+              <a:ext uri="{FF2B5EF4-FFF2-40B4-BE49-F238E27FC236}">
+                <a16:creationId xmlns:a16="http://schemas.microsoft.com/office/drawing/2014/main" id="{732CE815-4347-446C-A526-A4B34C56202C}"/>
               </a:ext>
             </a:extLst>
           </p:cNvPr>
@@ -4777,7 +4860,7 @@
         <p:spPr>
           <a:xfrm>
             <a:off x="4838700" y="4495800"/>
-            <a:ext cx="863600" cy="184666"/>
+            <a:ext cx="863600" cy="200055"/>
           </a:xfrm>
           <a:prstGeom prst="rect">
             <a:avLst/>
@@ -4792,7 +4875,7 @@
           <a:p>
             <a:pPr algn="ctr"/>
             <a:r>
-              <a:rPr lang="de-DE" sz="1200" b="1">
+              <a:rPr lang="de-DE" sz="1300" b="1">
                 <a:solidFill>
                   <a:srgbClr val="222222"/>
                 </a:solidFill>
@@ -4805,10 +4888,10 @@
       </p:sp>
       <p:sp>
         <p:nvSpPr>
-          <p:cNvPr id="35" name="Rechteck 34">
-            <a:extLst>
-              <a:ext uri="{FF2B5EF4-FFF2-40B4-BE49-F238E27FC236}">
-                <a16:creationId xmlns:a16="http://schemas.microsoft.com/office/drawing/2014/main" id="{D4D1192C-1B8D-17CE-B79F-9AB4EA9C2A2A}"/>
+          <p:cNvPr id="37" name="Rechteck 36">
+            <a:extLst>
+              <a:ext uri="{FF2B5EF4-FFF2-40B4-BE49-F238E27FC236}">
+                <a16:creationId xmlns:a16="http://schemas.microsoft.com/office/drawing/2014/main" id="{DE8F1D6E-BBC5-48FF-8B5F-68CAA862A749}"/>
               </a:ext>
             </a:extLst>
           </p:cNvPr>
@@ -4837,7 +4920,7 @@
         <p:style>
           <a:lnRef idx="2">
             <a:schemeClr val="accent1">
-              <a:shade val="15000"/>
+              <a:shade val="50000"/>
             </a:schemeClr>
           </a:lnRef>
           <a:fillRef idx="1">
@@ -4861,10 +4944,10 @@
       </p:sp>
       <p:sp>
         <p:nvSpPr>
-          <p:cNvPr id="36" name="Rechteck 35">
-            <a:extLst>
-              <a:ext uri="{FF2B5EF4-FFF2-40B4-BE49-F238E27FC236}">
-                <a16:creationId xmlns:a16="http://schemas.microsoft.com/office/drawing/2014/main" id="{466CBEF5-BB6F-658C-27A1-F623E90A657A}"/>
+          <p:cNvPr id="38" name="Rechteck 37">
+            <a:extLst>
+              <a:ext uri="{FF2B5EF4-FFF2-40B4-BE49-F238E27FC236}">
+                <a16:creationId xmlns:a16="http://schemas.microsoft.com/office/drawing/2014/main" id="{1358EEA5-D1E0-40C7-9B43-D34A00588A76}"/>
               </a:ext>
             </a:extLst>
           </p:cNvPr>
@@ -4893,7 +4976,7 @@
         <p:style>
           <a:lnRef idx="2">
             <a:schemeClr val="accent1">
-              <a:shade val="15000"/>
+              <a:shade val="50000"/>
             </a:schemeClr>
           </a:lnRef>
           <a:fillRef idx="1">
@@ -4917,10 +5000,10 @@
       </p:sp>
       <p:sp>
         <p:nvSpPr>
-          <p:cNvPr id="37" name="Textfeld 36">
-            <a:extLst>
-              <a:ext uri="{FF2B5EF4-FFF2-40B4-BE49-F238E27FC236}">
-                <a16:creationId xmlns:a16="http://schemas.microsoft.com/office/drawing/2014/main" id="{BB9A1A26-2249-EA1D-BB62-AB50A14EABB1}"/>
+          <p:cNvPr id="39" name="Textfeld 38">
+            <a:extLst>
+              <a:ext uri="{FF2B5EF4-FFF2-40B4-BE49-F238E27FC236}">
+                <a16:creationId xmlns:a16="http://schemas.microsoft.com/office/drawing/2014/main" id="{64401A34-6B71-408F-BCF3-3A47935ECB33}"/>
               </a:ext>
             </a:extLst>
           </p:cNvPr>
@@ -4929,8 +5012,8 @@
         </p:nvSpPr>
         <p:spPr>
           <a:xfrm>
-            <a:off x="3136900" y="165100"/>
-            <a:ext cx="660400" cy="169277"/>
+            <a:off x="3136900" y="152400"/>
+            <a:ext cx="660400" cy="184666"/>
           </a:xfrm>
           <a:prstGeom prst="rect">
             <a:avLst/>
@@ -4944,7 +5027,7 @@
           <a:lstStyle/>
           <a:p>
             <a:r>
-              <a:rPr lang="de-DE" sz="1100">
+              <a:rPr lang="de-DE" sz="1200">
                 <a:solidFill>
                   <a:srgbClr val="222222"/>
                 </a:solidFill>
@@ -4957,10 +5040,10 @@
       </p:sp>
       <p:sp>
         <p:nvSpPr>
-          <p:cNvPr id="38" name="Textfeld 37">
-            <a:extLst>
-              <a:ext uri="{FF2B5EF4-FFF2-40B4-BE49-F238E27FC236}">
-                <a16:creationId xmlns:a16="http://schemas.microsoft.com/office/drawing/2014/main" id="{0BEE7C56-0065-362E-E1D6-E613DA3DA567}"/>
+          <p:cNvPr id="40" name="Textfeld 39">
+            <a:extLst>
+              <a:ext uri="{FF2B5EF4-FFF2-40B4-BE49-F238E27FC236}">
+                <a16:creationId xmlns:a16="http://schemas.microsoft.com/office/drawing/2014/main" id="{E0A07780-3C29-4DC0-9C1F-235F3B9D656E}"/>
               </a:ext>
             </a:extLst>
           </p:cNvPr>
@@ -4969,8 +5052,8 @@
         </p:nvSpPr>
         <p:spPr>
           <a:xfrm>
-            <a:off x="4216400" y="165100"/>
-            <a:ext cx="736600" cy="169277"/>
+            <a:off x="4216400" y="152400"/>
+            <a:ext cx="736600" cy="184666"/>
           </a:xfrm>
           <a:prstGeom prst="rect">
             <a:avLst/>
@@ -4984,7 +5067,7 @@
           <a:lstStyle/>
           <a:p>
             <a:r>
-              <a:rPr lang="de-DE" sz="1100">
+              <a:rPr lang="de-DE" sz="1200">
                 <a:solidFill>
                   <a:srgbClr val="222222"/>
                 </a:solidFill>
@@ -4997,10 +5080,10 @@
       </p:sp>
       <p:sp>
         <p:nvSpPr>
-          <p:cNvPr id="39" name="Textfeld 38">
-            <a:extLst>
-              <a:ext uri="{FF2B5EF4-FFF2-40B4-BE49-F238E27FC236}">
-                <a16:creationId xmlns:a16="http://schemas.microsoft.com/office/drawing/2014/main" id="{A653D101-323E-1B8E-BA4C-FD1702FA86D6}"/>
+          <p:cNvPr id="41" name="Textfeld 40">
+            <a:extLst>
+              <a:ext uri="{FF2B5EF4-FFF2-40B4-BE49-F238E27FC236}">
+                <a16:creationId xmlns:a16="http://schemas.microsoft.com/office/drawing/2014/main" id="{5CB7CA4E-FA85-4E90-91B3-2533304B14DE}"/>
               </a:ext>
             </a:extLst>
           </p:cNvPr>
@@ -5010,7 +5093,7 @@
         <p:spPr>
           <a:xfrm rot="16200000">
             <a:off x="-698500" y="2387600"/>
-            <a:ext cx="2032000" cy="200055"/>
+            <a:ext cx="2032000" cy="215444"/>
           </a:xfrm>
           <a:prstGeom prst="rect">
             <a:avLst/>
@@ -5025,7 +5108,7 @@
           <a:p>
             <a:pPr algn="ctr"/>
             <a:r>
-              <a:rPr lang="de-DE" sz="1300">
+              <a:rPr lang="de-DE" sz="1400">
                 <a:solidFill>
                   <a:srgbClr val="222222"/>
                 </a:solidFill>
@@ -5038,10 +5121,10 @@
       </p:sp>
       <p:sp>
         <p:nvSpPr>
-          <p:cNvPr id="40" name="Textfeld 39">
-            <a:extLst>
-              <a:ext uri="{FF2B5EF4-FFF2-40B4-BE49-F238E27FC236}">
-                <a16:creationId xmlns:a16="http://schemas.microsoft.com/office/drawing/2014/main" id="{EA9A333A-8070-397B-322E-0A35ECDEFCDF}"/>
+          <p:cNvPr id="42" name="Textfeld 41">
+            <a:extLst>
+              <a:ext uri="{FF2B5EF4-FFF2-40B4-BE49-F238E27FC236}">
+                <a16:creationId xmlns:a16="http://schemas.microsoft.com/office/drawing/2014/main" id="{DBD3262F-20A3-412E-8739-99E234FF9663}"/>
               </a:ext>
             </a:extLst>
           </p:cNvPr>
@@ -5051,7 +5134,7 @@
         <p:spPr>
           <a:xfrm>
             <a:off x="2413000" y="5054600"/>
-            <a:ext cx="2222500" cy="200055"/>
+            <a:ext cx="2222500" cy="215444"/>
           </a:xfrm>
           <a:prstGeom prst="rect">
             <a:avLst/>
@@ -5066,7 +5149,7 @@
           <a:p>
             <a:pPr algn="ctr"/>
             <a:r>
-              <a:rPr lang="de-DE" sz="1300">
+              <a:rPr lang="de-DE" sz="1400">
                 <a:solidFill>
                   <a:srgbClr val="222222"/>
                 </a:solidFill>
@@ -5079,10 +5162,10 @@
       </p:sp>
       <p:sp>
         <p:nvSpPr>
-          <p:cNvPr id="41" name="Textfeld 40">
-            <a:extLst>
-              <a:ext uri="{FF2B5EF4-FFF2-40B4-BE49-F238E27FC236}">
-                <a16:creationId xmlns:a16="http://schemas.microsoft.com/office/drawing/2014/main" id="{3A8D34EA-D382-F13E-454C-6D6C67D1D1A2}"/>
+          <p:cNvPr id="43" name="Textfeld 42">
+            <a:extLst>
+              <a:ext uri="{FF2B5EF4-FFF2-40B4-BE49-F238E27FC236}">
+                <a16:creationId xmlns:a16="http://schemas.microsoft.com/office/drawing/2014/main" id="{311CB3F6-88A3-4CB3-B915-016F4833DFD7}"/>
               </a:ext>
             </a:extLst>
           </p:cNvPr>
@@ -5119,10 +5202,10 @@
       </p:sp>
       <p:cxnSp>
         <p:nvCxnSpPr>
-          <p:cNvPr id="42" name="Gerader Verbinder 41">
-            <a:extLst>
-              <a:ext uri="{FF2B5EF4-FFF2-40B4-BE49-F238E27FC236}">
-                <a16:creationId xmlns:a16="http://schemas.microsoft.com/office/drawing/2014/main" id="{27A42A2C-1CC7-0739-B1EA-DD12905B6A89}"/>
+          <p:cNvPr id="44" name="Gerader Verbinder 43">
+            <a:extLst>
+              <a:ext uri="{FF2B5EF4-FFF2-40B4-BE49-F238E27FC236}">
+                <a16:creationId xmlns:a16="http://schemas.microsoft.com/office/drawing/2014/main" id="{3370ECA2-A024-4698-A1B4-B5D8BA338DFF}"/>
               </a:ext>
             </a:extLst>
           </p:cNvPr>
@@ -5144,13 +5227,13 @@
           </a:ln>
         </p:spPr>
         <p:style>
-          <a:lnRef idx="2">
+          <a:lnRef idx="1">
             <a:schemeClr val="accent1"/>
           </a:lnRef>
           <a:fillRef idx="0">
             <a:schemeClr val="accent1"/>
           </a:fillRef>
-          <a:effectRef idx="1">
+          <a:effectRef idx="0">
             <a:schemeClr val="accent1"/>
           </a:effectRef>
           <a:fontRef idx="minor">
@@ -5160,10 +5243,10 @@
       </p:cxnSp>
       <p:sp>
         <p:nvSpPr>
-          <p:cNvPr id="43" name="Textfeld 42">
-            <a:extLst>
-              <a:ext uri="{FF2B5EF4-FFF2-40B4-BE49-F238E27FC236}">
-                <a16:creationId xmlns:a16="http://schemas.microsoft.com/office/drawing/2014/main" id="{D170C098-1CB5-EA82-2324-2554E6BF992A}"/>
+          <p:cNvPr id="45" name="Textfeld 44">
+            <a:extLst>
+              <a:ext uri="{FF2B5EF4-FFF2-40B4-BE49-F238E27FC236}">
+                <a16:creationId xmlns:a16="http://schemas.microsoft.com/office/drawing/2014/main" id="{E1F58740-75B2-45B0-8335-7DCA5EDDBBE4}"/>
               </a:ext>
             </a:extLst>
           </p:cNvPr>
@@ -5172,8 +5255,8 @@
         </p:nvSpPr>
         <p:spPr>
           <a:xfrm>
-            <a:off x="6832600" y="4318000"/>
-            <a:ext cx="393700" cy="153888"/>
+            <a:off x="6794500" y="4305300"/>
+            <a:ext cx="431800" cy="169277"/>
           </a:xfrm>
           <a:prstGeom prst="rect">
             <a:avLst/>
@@ -5188,7 +5271,7 @@
           <a:p>
             <a:pPr algn="r"/>
             <a:r>
-              <a:rPr lang="de-DE" sz="1000">
+              <a:rPr lang="de-DE" sz="1100">
                 <a:solidFill>
                   <a:srgbClr val="222222"/>
                 </a:solidFill>
@@ -5201,10 +5284,10 @@
       </p:sp>
       <p:cxnSp>
         <p:nvCxnSpPr>
-          <p:cNvPr id="44" name="Gerader Verbinder 43">
-            <a:extLst>
-              <a:ext uri="{FF2B5EF4-FFF2-40B4-BE49-F238E27FC236}">
-                <a16:creationId xmlns:a16="http://schemas.microsoft.com/office/drawing/2014/main" id="{117A5195-B408-B1DC-A75B-A9A4B50BE23E}"/>
+          <p:cNvPr id="46" name="Gerader Verbinder 45">
+            <a:extLst>
+              <a:ext uri="{FF2B5EF4-FFF2-40B4-BE49-F238E27FC236}">
+                <a16:creationId xmlns:a16="http://schemas.microsoft.com/office/drawing/2014/main" id="{2BE1E651-E950-4115-829D-F735417ABD1D}"/>
               </a:ext>
             </a:extLst>
           </p:cNvPr>
@@ -5227,13 +5310,13 @@
           </a:ln>
         </p:spPr>
         <p:style>
-          <a:lnRef idx="2">
+          <a:lnRef idx="1">
             <a:schemeClr val="accent1"/>
           </a:lnRef>
           <a:fillRef idx="0">
             <a:schemeClr val="accent1"/>
           </a:fillRef>
-          <a:effectRef idx="1">
+          <a:effectRef idx="0">
             <a:schemeClr val="accent1"/>
           </a:effectRef>
           <a:fontRef idx="minor">
@@ -5243,10 +5326,10 @@
       </p:cxnSp>
       <p:sp>
         <p:nvSpPr>
-          <p:cNvPr id="45" name="Textfeld 44">
-            <a:extLst>
-              <a:ext uri="{FF2B5EF4-FFF2-40B4-BE49-F238E27FC236}">
-                <a16:creationId xmlns:a16="http://schemas.microsoft.com/office/drawing/2014/main" id="{84A011E5-7C8A-645E-6182-4CCD414B192B}"/>
+          <p:cNvPr id="47" name="Textfeld 46">
+            <a:extLst>
+              <a:ext uri="{FF2B5EF4-FFF2-40B4-BE49-F238E27FC236}">
+                <a16:creationId xmlns:a16="http://schemas.microsoft.com/office/drawing/2014/main" id="{07AA5A7F-B482-4143-A8E0-86D8E954C8C1}"/>
               </a:ext>
             </a:extLst>
           </p:cNvPr>
@@ -5255,8 +5338,8 @@
         </p:nvSpPr>
         <p:spPr>
           <a:xfrm>
-            <a:off x="6832600" y="3365500"/>
-            <a:ext cx="393700" cy="153888"/>
+            <a:off x="6794500" y="3352800"/>
+            <a:ext cx="431800" cy="169277"/>
           </a:xfrm>
           <a:prstGeom prst="rect">
             <a:avLst/>
@@ -5271,7 +5354,7 @@
           <a:p>
             <a:pPr algn="r"/>
             <a:r>
-              <a:rPr lang="de-DE" sz="1000">
+              <a:rPr lang="de-DE" sz="1100">
                 <a:solidFill>
                   <a:srgbClr val="222222"/>
                 </a:solidFill>
@@ -5284,10 +5367,10 @@
       </p:sp>
       <p:cxnSp>
         <p:nvCxnSpPr>
-          <p:cNvPr id="46" name="Gerader Verbinder 45">
-            <a:extLst>
-              <a:ext uri="{FF2B5EF4-FFF2-40B4-BE49-F238E27FC236}">
-                <a16:creationId xmlns:a16="http://schemas.microsoft.com/office/drawing/2014/main" id="{1F037507-0E73-5B5E-1971-6F6B0ABA0135}"/>
+          <p:cNvPr id="48" name="Gerader Verbinder 47">
+            <a:extLst>
+              <a:ext uri="{FF2B5EF4-FFF2-40B4-BE49-F238E27FC236}">
+                <a16:creationId xmlns:a16="http://schemas.microsoft.com/office/drawing/2014/main" id="{98DFD846-1F5C-4E0A-A16E-24EA285EFE30}"/>
               </a:ext>
             </a:extLst>
           </p:cNvPr>
@@ -5310,13 +5393,13 @@
           </a:ln>
         </p:spPr>
         <p:style>
-          <a:lnRef idx="2">
+          <a:lnRef idx="1">
             <a:schemeClr val="accent1"/>
           </a:lnRef>
           <a:fillRef idx="0">
             <a:schemeClr val="accent1"/>
           </a:fillRef>
-          <a:effectRef idx="1">
+          <a:effectRef idx="0">
             <a:schemeClr val="accent1"/>
           </a:effectRef>
           <a:fontRef idx="minor">
@@ -5326,10 +5409,10 @@
       </p:cxnSp>
       <p:sp>
         <p:nvSpPr>
-          <p:cNvPr id="47" name="Textfeld 46">
-            <a:extLst>
-              <a:ext uri="{FF2B5EF4-FFF2-40B4-BE49-F238E27FC236}">
-                <a16:creationId xmlns:a16="http://schemas.microsoft.com/office/drawing/2014/main" id="{D32F49BF-F0EC-9BA9-73CF-EA2CCE2E68B7}"/>
+          <p:cNvPr id="49" name="Textfeld 48">
+            <a:extLst>
+              <a:ext uri="{FF2B5EF4-FFF2-40B4-BE49-F238E27FC236}">
+                <a16:creationId xmlns:a16="http://schemas.microsoft.com/office/drawing/2014/main" id="{7C089A91-27AE-4B4D-A5FA-D590ADB0487B}"/>
               </a:ext>
             </a:extLst>
           </p:cNvPr>
@@ -5338,8 +5421,8 @@
         </p:nvSpPr>
         <p:spPr>
           <a:xfrm>
-            <a:off x="6832600" y="2413000"/>
-            <a:ext cx="393700" cy="153888"/>
+            <a:off x="6794500" y="2400300"/>
+            <a:ext cx="431800" cy="169277"/>
           </a:xfrm>
           <a:prstGeom prst="rect">
             <a:avLst/>
@@ -5354,7 +5437,7 @@
           <a:p>
             <a:pPr algn="r"/>
             <a:r>
-              <a:rPr lang="de-DE" sz="1000">
+              <a:rPr lang="de-DE" sz="1100">
                 <a:solidFill>
                   <a:srgbClr val="222222"/>
                 </a:solidFill>
@@ -5367,10 +5450,10 @@
       </p:sp>
       <p:cxnSp>
         <p:nvCxnSpPr>
-          <p:cNvPr id="48" name="Gerader Verbinder 47">
-            <a:extLst>
-              <a:ext uri="{FF2B5EF4-FFF2-40B4-BE49-F238E27FC236}">
-                <a16:creationId xmlns:a16="http://schemas.microsoft.com/office/drawing/2014/main" id="{F74B7F7D-D91A-EBA1-72AE-AC96F20A75E1}"/>
+          <p:cNvPr id="50" name="Gerader Verbinder 49">
+            <a:extLst>
+              <a:ext uri="{FF2B5EF4-FFF2-40B4-BE49-F238E27FC236}">
+                <a16:creationId xmlns:a16="http://schemas.microsoft.com/office/drawing/2014/main" id="{0A47D323-DE16-4B4A-9294-23FF290DF0CF}"/>
               </a:ext>
             </a:extLst>
           </p:cNvPr>
@@ -5393,13 +5476,13 @@
           </a:ln>
         </p:spPr>
         <p:style>
-          <a:lnRef idx="2">
+          <a:lnRef idx="1">
             <a:schemeClr val="accent1"/>
           </a:lnRef>
           <a:fillRef idx="0">
             <a:schemeClr val="accent1"/>
           </a:fillRef>
-          <a:effectRef idx="1">
+          <a:effectRef idx="0">
             <a:schemeClr val="accent1"/>
           </a:effectRef>
           <a:fontRef idx="minor">
@@ -5409,10 +5492,10 @@
       </p:cxnSp>
       <p:sp>
         <p:nvSpPr>
-          <p:cNvPr id="49" name="Textfeld 48">
-            <a:extLst>
-              <a:ext uri="{FF2B5EF4-FFF2-40B4-BE49-F238E27FC236}">
-                <a16:creationId xmlns:a16="http://schemas.microsoft.com/office/drawing/2014/main" id="{D65C0376-BC2E-9A50-B6FB-9283E4E2ECCE}"/>
+          <p:cNvPr id="51" name="Textfeld 50">
+            <a:extLst>
+              <a:ext uri="{FF2B5EF4-FFF2-40B4-BE49-F238E27FC236}">
+                <a16:creationId xmlns:a16="http://schemas.microsoft.com/office/drawing/2014/main" id="{83261474-A516-4BB1-9527-6F01E0F7DED3}"/>
               </a:ext>
             </a:extLst>
           </p:cNvPr>
@@ -5421,8 +5504,8 @@
         </p:nvSpPr>
         <p:spPr>
           <a:xfrm>
-            <a:off x="6832600" y="1460500"/>
-            <a:ext cx="393700" cy="153888"/>
+            <a:off x="6794500" y="1447800"/>
+            <a:ext cx="431800" cy="169277"/>
           </a:xfrm>
           <a:prstGeom prst="rect">
             <a:avLst/>
@@ -5437,7 +5520,7 @@
           <a:p>
             <a:pPr algn="r"/>
             <a:r>
-              <a:rPr lang="de-DE" sz="1000">
+              <a:rPr lang="de-DE" sz="1100">
                 <a:solidFill>
                   <a:srgbClr val="222222"/>
                 </a:solidFill>
@@ -5450,10 +5533,10 @@
       </p:sp>
       <p:cxnSp>
         <p:nvCxnSpPr>
-          <p:cNvPr id="50" name="Gerader Verbinder 49">
-            <a:extLst>
-              <a:ext uri="{FF2B5EF4-FFF2-40B4-BE49-F238E27FC236}">
-                <a16:creationId xmlns:a16="http://schemas.microsoft.com/office/drawing/2014/main" id="{FCE072C5-ED64-2819-360C-3DBB6503AD88}"/>
+          <p:cNvPr id="52" name="Gerader Verbinder 51">
+            <a:extLst>
+              <a:ext uri="{FF2B5EF4-FFF2-40B4-BE49-F238E27FC236}">
+                <a16:creationId xmlns:a16="http://schemas.microsoft.com/office/drawing/2014/main" id="{A71BE61C-CDAB-40DA-8061-C5CB5893DD71}"/>
               </a:ext>
             </a:extLst>
           </p:cNvPr>
@@ -5476,13 +5559,13 @@
           </a:ln>
         </p:spPr>
         <p:style>
-          <a:lnRef idx="2">
+          <a:lnRef idx="1">
             <a:schemeClr val="accent1"/>
           </a:lnRef>
           <a:fillRef idx="0">
             <a:schemeClr val="accent1"/>
           </a:fillRef>
-          <a:effectRef idx="1">
+          <a:effectRef idx="0">
             <a:schemeClr val="accent1"/>
           </a:effectRef>
           <a:fontRef idx="minor">
@@ -5492,10 +5575,10 @@
       </p:cxnSp>
       <p:sp>
         <p:nvSpPr>
-          <p:cNvPr id="51" name="Textfeld 50">
-            <a:extLst>
-              <a:ext uri="{FF2B5EF4-FFF2-40B4-BE49-F238E27FC236}">
-                <a16:creationId xmlns:a16="http://schemas.microsoft.com/office/drawing/2014/main" id="{D1649239-1C9D-F43B-2550-FDAAFA3EB161}"/>
+          <p:cNvPr id="53" name="Textfeld 52">
+            <a:extLst>
+              <a:ext uri="{FF2B5EF4-FFF2-40B4-BE49-F238E27FC236}">
+                <a16:creationId xmlns:a16="http://schemas.microsoft.com/office/drawing/2014/main" id="{D8B0566B-8435-4D2A-B640-EF280EA39452}"/>
               </a:ext>
             </a:extLst>
           </p:cNvPr>
@@ -5504,8 +5587,8 @@
         </p:nvSpPr>
         <p:spPr>
           <a:xfrm>
-            <a:off x="6832600" y="508000"/>
-            <a:ext cx="393700" cy="153888"/>
+            <a:off x="6794500" y="495300"/>
+            <a:ext cx="431800" cy="169277"/>
           </a:xfrm>
           <a:prstGeom prst="rect">
             <a:avLst/>
@@ -5520,7 +5603,7 @@
           <a:p>
             <a:pPr algn="r"/>
             <a:r>
-              <a:rPr lang="de-DE" sz="1000">
+              <a:rPr lang="de-DE" sz="1100">
                 <a:solidFill>
                   <a:srgbClr val="222222"/>
                 </a:solidFill>
@@ -5533,10 +5616,10 @@
       </p:sp>
       <p:cxnSp>
         <p:nvCxnSpPr>
-          <p:cNvPr id="52" name="Gerader Verbinder 51">
-            <a:extLst>
-              <a:ext uri="{FF2B5EF4-FFF2-40B4-BE49-F238E27FC236}">
-                <a16:creationId xmlns:a16="http://schemas.microsoft.com/office/drawing/2014/main" id="{5BB46A68-06C7-B872-2A56-FE1085D66AF7}"/>
+          <p:cNvPr id="54" name="Gerader Verbinder 53">
+            <a:extLst>
+              <a:ext uri="{FF2B5EF4-FFF2-40B4-BE49-F238E27FC236}">
+                <a16:creationId xmlns:a16="http://schemas.microsoft.com/office/drawing/2014/main" id="{149A4EF5-975F-4E82-B30E-6ED5ED9B281C}"/>
               </a:ext>
             </a:extLst>
           </p:cNvPr>
@@ -5558,13 +5641,13 @@
           </a:ln>
         </p:spPr>
         <p:style>
-          <a:lnRef idx="2">
+          <a:lnRef idx="1">
             <a:schemeClr val="accent1"/>
           </a:lnRef>
           <a:fillRef idx="0">
             <a:schemeClr val="accent1"/>
           </a:fillRef>
-          <a:effectRef idx="1">
+          <a:effectRef idx="0">
             <a:schemeClr val="accent1"/>
           </a:effectRef>
           <a:fontRef idx="minor">
@@ -5574,10 +5657,10 @@
       </p:cxnSp>
       <p:cxnSp>
         <p:nvCxnSpPr>
-          <p:cNvPr id="53" name="Gerader Verbinder 52">
-            <a:extLst>
-              <a:ext uri="{FF2B5EF4-FFF2-40B4-BE49-F238E27FC236}">
-                <a16:creationId xmlns:a16="http://schemas.microsoft.com/office/drawing/2014/main" id="{C34E9F88-D42D-00CE-84EF-8DFDA0050D7B}"/>
+          <p:cNvPr id="55" name="Gerader Verbinder 54">
+            <a:extLst>
+              <a:ext uri="{FF2B5EF4-FFF2-40B4-BE49-F238E27FC236}">
+                <a16:creationId xmlns:a16="http://schemas.microsoft.com/office/drawing/2014/main" id="{8B93CFAB-6459-48E2-9458-904A1E54CCDE}"/>
               </a:ext>
             </a:extLst>
           </p:cNvPr>
@@ -5599,13 +5682,13 @@
           </a:ln>
         </p:spPr>
         <p:style>
-          <a:lnRef idx="2">
+          <a:lnRef idx="1">
             <a:schemeClr val="accent1"/>
           </a:lnRef>
           <a:fillRef idx="0">
             <a:schemeClr val="accent1"/>
           </a:fillRef>
-          <a:effectRef idx="1">
+          <a:effectRef idx="0">
             <a:schemeClr val="accent1"/>
           </a:effectRef>
           <a:fontRef idx="minor">
@@ -5615,10 +5698,10 @@
       </p:cxnSp>
       <p:sp>
         <p:nvSpPr>
-          <p:cNvPr id="54" name="Rechteck 53">
-            <a:extLst>
-              <a:ext uri="{FF2B5EF4-FFF2-40B4-BE49-F238E27FC236}">
-                <a16:creationId xmlns:a16="http://schemas.microsoft.com/office/drawing/2014/main" id="{AF81DD5E-C59E-588A-2448-50790416D06B}"/>
+          <p:cNvPr id="56" name="Rechteck 55">
+            <a:extLst>
+              <a:ext uri="{FF2B5EF4-FFF2-40B4-BE49-F238E27FC236}">
+                <a16:creationId xmlns:a16="http://schemas.microsoft.com/office/drawing/2014/main" id="{0A4AC3B8-C6B2-4C30-8698-EBF8AF82BD5F}"/>
               </a:ext>
             </a:extLst>
           </p:cNvPr>
@@ -5627,8 +5710,8 @@
         </p:nvSpPr>
         <p:spPr>
           <a:xfrm>
-            <a:off x="7683500" y="2590800"/>
-            <a:ext cx="635000" cy="1828800"/>
+            <a:off x="7683500" y="2590871"/>
+            <a:ext cx="635000" cy="1828729"/>
           </a:xfrm>
           <a:prstGeom prst="rect">
             <a:avLst/>
@@ -5647,7 +5730,7 @@
         <p:style>
           <a:lnRef idx="2">
             <a:schemeClr val="accent1">
-              <a:shade val="15000"/>
+              <a:shade val="50000"/>
             </a:schemeClr>
           </a:lnRef>
           <a:fillRef idx="1">
@@ -5671,10 +5754,10 @@
       </p:sp>
       <p:sp>
         <p:nvSpPr>
-          <p:cNvPr id="55" name="Textfeld 54">
-            <a:extLst>
-              <a:ext uri="{FF2B5EF4-FFF2-40B4-BE49-F238E27FC236}">
-                <a16:creationId xmlns:a16="http://schemas.microsoft.com/office/drawing/2014/main" id="{A755D18C-D803-5073-DD25-F31DD9EE3DBA}"/>
+          <p:cNvPr id="57" name="Textfeld 56">
+            <a:extLst>
+              <a:ext uri="{FF2B5EF4-FFF2-40B4-BE49-F238E27FC236}">
+                <a16:creationId xmlns:a16="http://schemas.microsoft.com/office/drawing/2014/main" id="{41B8200E-EA50-406B-A47A-BA4C0B2809A9}"/>
               </a:ext>
             </a:extLst>
           </p:cNvPr>
@@ -5683,8 +5766,8 @@
         </p:nvSpPr>
         <p:spPr>
           <a:xfrm>
-            <a:off x="7556500" y="2336800"/>
-            <a:ext cx="889000" cy="153888"/>
+            <a:off x="7556500" y="2324171"/>
+            <a:ext cx="889000" cy="169277"/>
           </a:xfrm>
           <a:prstGeom prst="rect">
             <a:avLst/>
@@ -5699,7 +5782,7 @@
           <a:p>
             <a:pPr algn="ctr"/>
             <a:r>
-              <a:rPr lang="de-DE" sz="1000">
+              <a:rPr lang="de-DE" sz="1100">
                 <a:solidFill>
                   <a:srgbClr val="222222"/>
                 </a:solidFill>
@@ -5712,10 +5795,10 @@
       </p:sp>
       <p:sp>
         <p:nvSpPr>
-          <p:cNvPr id="56" name="Textfeld 55">
-            <a:extLst>
-              <a:ext uri="{FF2B5EF4-FFF2-40B4-BE49-F238E27FC236}">
-                <a16:creationId xmlns:a16="http://schemas.microsoft.com/office/drawing/2014/main" id="{30EEF62A-3540-D08F-D9EB-506AD3A247A8}"/>
+          <p:cNvPr id="58" name="Textfeld 57">
+            <a:extLst>
+              <a:ext uri="{FF2B5EF4-FFF2-40B4-BE49-F238E27FC236}">
+                <a16:creationId xmlns:a16="http://schemas.microsoft.com/office/drawing/2014/main" id="{FB545285-F2E8-43BF-B5AE-E692F45462F4}"/>
               </a:ext>
             </a:extLst>
           </p:cNvPr>
@@ -5725,7 +5808,7 @@
         <p:spPr>
           <a:xfrm>
             <a:off x="7569200" y="4495800"/>
-            <a:ext cx="863600" cy="184666"/>
+            <a:ext cx="863600" cy="200055"/>
           </a:xfrm>
           <a:prstGeom prst="rect">
             <a:avLst/>
@@ -5740,7 +5823,7 @@
           <a:p>
             <a:pPr algn="ctr"/>
             <a:r>
-              <a:rPr lang="de-DE" sz="1200" b="1">
+              <a:rPr lang="de-DE" sz="1300" b="1">
                 <a:solidFill>
                   <a:srgbClr val="222222"/>
                 </a:solidFill>
@@ -5753,10 +5836,10 @@
       </p:sp>
       <p:sp>
         <p:nvSpPr>
-          <p:cNvPr id="57" name="Rechteck 56">
-            <a:extLst>
-              <a:ext uri="{FF2B5EF4-FFF2-40B4-BE49-F238E27FC236}">
-                <a16:creationId xmlns:a16="http://schemas.microsoft.com/office/drawing/2014/main" id="{79361A2E-BB16-120C-9CB4-09C5C75D81A7}"/>
+          <p:cNvPr id="59" name="Rechteck 58">
+            <a:extLst>
+              <a:ext uri="{FF2B5EF4-FFF2-40B4-BE49-F238E27FC236}">
+                <a16:creationId xmlns:a16="http://schemas.microsoft.com/office/drawing/2014/main" id="{CF6D42A0-616C-4634-8478-11B362376C5F}"/>
               </a:ext>
             </a:extLst>
           </p:cNvPr>
@@ -5765,8 +5848,8 @@
         </p:nvSpPr>
         <p:spPr>
           <a:xfrm>
-            <a:off x="8890000" y="1351598"/>
-            <a:ext cx="635000" cy="3068002"/>
+            <a:off x="8890000" y="1351760"/>
+            <a:ext cx="635000" cy="3067840"/>
           </a:xfrm>
           <a:prstGeom prst="rect">
             <a:avLst/>
@@ -5785,7 +5868,7 @@
         <p:style>
           <a:lnRef idx="2">
             <a:schemeClr val="accent1">
-              <a:shade val="15000"/>
+              <a:shade val="50000"/>
             </a:schemeClr>
           </a:lnRef>
           <a:fillRef idx="1">
@@ -5809,10 +5892,10 @@
       </p:sp>
       <p:sp>
         <p:nvSpPr>
-          <p:cNvPr id="58" name="Textfeld 57">
-            <a:extLst>
-              <a:ext uri="{FF2B5EF4-FFF2-40B4-BE49-F238E27FC236}">
-                <a16:creationId xmlns:a16="http://schemas.microsoft.com/office/drawing/2014/main" id="{BE28DA2A-FBC1-4CAC-63FC-B215FADD1F01}"/>
+          <p:cNvPr id="60" name="Textfeld 59">
+            <a:extLst>
+              <a:ext uri="{FF2B5EF4-FFF2-40B4-BE49-F238E27FC236}">
+                <a16:creationId xmlns:a16="http://schemas.microsoft.com/office/drawing/2014/main" id="{970A0F11-42F9-4559-9B8A-858EBA46D7A1}"/>
               </a:ext>
             </a:extLst>
           </p:cNvPr>
@@ -5821,8 +5904,8 @@
         </p:nvSpPr>
         <p:spPr>
           <a:xfrm>
-            <a:off x="8763000" y="1097598"/>
-            <a:ext cx="889000" cy="153888"/>
+            <a:off x="8763000" y="1085060"/>
+            <a:ext cx="889000" cy="169277"/>
           </a:xfrm>
           <a:prstGeom prst="rect">
             <a:avLst/>
@@ -5837,7 +5920,7 @@
           <a:p>
             <a:pPr algn="ctr"/>
             <a:r>
-              <a:rPr lang="de-DE" sz="1000">
+              <a:rPr lang="de-DE" sz="1100">
                 <a:solidFill>
                   <a:srgbClr val="222222"/>
                 </a:solidFill>
@@ -5850,10 +5933,10 @@
       </p:sp>
       <p:sp>
         <p:nvSpPr>
-          <p:cNvPr id="59" name="Textfeld 58">
-            <a:extLst>
-              <a:ext uri="{FF2B5EF4-FFF2-40B4-BE49-F238E27FC236}">
-                <a16:creationId xmlns:a16="http://schemas.microsoft.com/office/drawing/2014/main" id="{3AE8959C-F7F8-F0B2-6654-FD4EFCFCEF6E}"/>
+          <p:cNvPr id="61" name="Textfeld 60">
+            <a:extLst>
+              <a:ext uri="{FF2B5EF4-FFF2-40B4-BE49-F238E27FC236}">
+                <a16:creationId xmlns:a16="http://schemas.microsoft.com/office/drawing/2014/main" id="{1288FF82-CD8E-4376-9BCB-2C350BC18AE5}"/>
               </a:ext>
             </a:extLst>
           </p:cNvPr>
@@ -5863,7 +5946,7 @@
         <p:spPr>
           <a:xfrm>
             <a:off x="8775700" y="4495800"/>
-            <a:ext cx="863600" cy="184666"/>
+            <a:ext cx="863600" cy="200055"/>
           </a:xfrm>
           <a:prstGeom prst="rect">
             <a:avLst/>
@@ -5878,7 +5961,7 @@
           <a:p>
             <a:pPr algn="ctr"/>
             <a:r>
-              <a:rPr lang="de-DE" sz="1200" b="1">
+              <a:rPr lang="de-DE" sz="1300" b="1">
                 <a:solidFill>
                   <a:srgbClr val="222222"/>
                 </a:solidFill>
@@ -5891,10 +5974,10 @@
       </p:sp>
       <p:sp>
         <p:nvSpPr>
-          <p:cNvPr id="60" name="Rechteck 59">
-            <a:extLst>
-              <a:ext uri="{FF2B5EF4-FFF2-40B4-BE49-F238E27FC236}">
-                <a16:creationId xmlns:a16="http://schemas.microsoft.com/office/drawing/2014/main" id="{8DF2EF55-6368-A962-82B2-CD9E20758ACC}"/>
+          <p:cNvPr id="62" name="Rechteck 61">
+            <a:extLst>
+              <a:ext uri="{FF2B5EF4-FFF2-40B4-BE49-F238E27FC236}">
+                <a16:creationId xmlns:a16="http://schemas.microsoft.com/office/drawing/2014/main" id="{0F08C073-85E2-48C7-8136-767CF23C337C}"/>
               </a:ext>
             </a:extLst>
           </p:cNvPr>
@@ -5903,8 +5986,8 @@
         </p:nvSpPr>
         <p:spPr>
           <a:xfrm>
-            <a:off x="10096500" y="1163955"/>
-            <a:ext cx="635000" cy="3255645"/>
+            <a:off x="10096500" y="1164214"/>
+            <a:ext cx="635000" cy="3255386"/>
           </a:xfrm>
           <a:prstGeom prst="rect">
             <a:avLst/>
@@ -5923,7 +6006,7 @@
         <p:style>
           <a:lnRef idx="2">
             <a:schemeClr val="accent1">
-              <a:shade val="15000"/>
+              <a:shade val="50000"/>
             </a:schemeClr>
           </a:lnRef>
           <a:fillRef idx="1">
@@ -5947,10 +6030,10 @@
       </p:sp>
       <p:sp>
         <p:nvSpPr>
-          <p:cNvPr id="61" name="Textfeld 60">
-            <a:extLst>
-              <a:ext uri="{FF2B5EF4-FFF2-40B4-BE49-F238E27FC236}">
-                <a16:creationId xmlns:a16="http://schemas.microsoft.com/office/drawing/2014/main" id="{32EB33AE-E0F3-98AE-9886-9E6126445246}"/>
+          <p:cNvPr id="63" name="Textfeld 62">
+            <a:extLst>
+              <a:ext uri="{FF2B5EF4-FFF2-40B4-BE49-F238E27FC236}">
+                <a16:creationId xmlns:a16="http://schemas.microsoft.com/office/drawing/2014/main" id="{0396BB70-09C9-4E43-8505-2FACC53E1BE5}"/>
               </a:ext>
             </a:extLst>
           </p:cNvPr>
@@ -5959,8 +6042,8 @@
         </p:nvSpPr>
         <p:spPr>
           <a:xfrm>
-            <a:off x="9969500" y="909955"/>
-            <a:ext cx="889000" cy="153888"/>
+            <a:off x="9969500" y="897514"/>
+            <a:ext cx="889000" cy="169277"/>
           </a:xfrm>
           <a:prstGeom prst="rect">
             <a:avLst/>
@@ -5975,7 +6058,7 @@
           <a:p>
             <a:pPr algn="ctr"/>
             <a:r>
-              <a:rPr lang="de-DE" sz="1000">
+              <a:rPr lang="de-DE" sz="1100">
                 <a:solidFill>
                   <a:srgbClr val="222222"/>
                 </a:solidFill>
@@ -5988,10 +6071,10 @@
       </p:sp>
       <p:sp>
         <p:nvSpPr>
-          <p:cNvPr id="62" name="Textfeld 61">
-            <a:extLst>
-              <a:ext uri="{FF2B5EF4-FFF2-40B4-BE49-F238E27FC236}">
-                <a16:creationId xmlns:a16="http://schemas.microsoft.com/office/drawing/2014/main" id="{58CA13E1-09BB-B73B-4EF8-49E7227E193F}"/>
+          <p:cNvPr id="64" name="Textfeld 63">
+            <a:extLst>
+              <a:ext uri="{FF2B5EF4-FFF2-40B4-BE49-F238E27FC236}">
+                <a16:creationId xmlns:a16="http://schemas.microsoft.com/office/drawing/2014/main" id="{35DD5903-6844-4CDE-8F44-230B6D8FD071}"/>
               </a:ext>
             </a:extLst>
           </p:cNvPr>
@@ -6001,7 +6084,7 @@
         <p:spPr>
           <a:xfrm>
             <a:off x="9982200" y="4495800"/>
-            <a:ext cx="863600" cy="184666"/>
+            <a:ext cx="863600" cy="200055"/>
           </a:xfrm>
           <a:prstGeom prst="rect">
             <a:avLst/>
@@ -6016,7 +6099,7 @@
           <a:p>
             <a:pPr algn="ctr"/>
             <a:r>
-              <a:rPr lang="de-DE" sz="1200" b="1">
+              <a:rPr lang="de-DE" sz="1300" b="1">
                 <a:solidFill>
                   <a:srgbClr val="222222"/>
                 </a:solidFill>
@@ -6029,10 +6112,10 @@
       </p:sp>
       <p:sp>
         <p:nvSpPr>
-          <p:cNvPr id="63" name="Rechteck 62">
-            <a:extLst>
-              <a:ext uri="{FF2B5EF4-FFF2-40B4-BE49-F238E27FC236}">
-                <a16:creationId xmlns:a16="http://schemas.microsoft.com/office/drawing/2014/main" id="{7B0925F1-5B60-90CB-95ED-ADC40D203F16}"/>
+          <p:cNvPr id="65" name="Rechteck 64">
+            <a:extLst>
+              <a:ext uri="{FF2B5EF4-FFF2-40B4-BE49-F238E27FC236}">
+                <a16:creationId xmlns:a16="http://schemas.microsoft.com/office/drawing/2014/main" id="{B3A571D7-C132-4112-A6B6-C15CCB680C4B}"/>
               </a:ext>
             </a:extLst>
           </p:cNvPr>
@@ -6041,8 +6124,8 @@
         </p:nvSpPr>
         <p:spPr>
           <a:xfrm>
-            <a:off x="11303000" y="2821305"/>
-            <a:ext cx="635000" cy="1598295"/>
+            <a:off x="11303000" y="2821438"/>
+            <a:ext cx="635000" cy="1598162"/>
           </a:xfrm>
           <a:prstGeom prst="rect">
             <a:avLst/>
@@ -6061,7 +6144,7 @@
         <p:style>
           <a:lnRef idx="2">
             <a:schemeClr val="accent1">
-              <a:shade val="15000"/>
+              <a:shade val="50000"/>
             </a:schemeClr>
           </a:lnRef>
           <a:fillRef idx="1">
@@ -6085,10 +6168,10 @@
       </p:sp>
       <p:sp>
         <p:nvSpPr>
-          <p:cNvPr id="64" name="Textfeld 63">
-            <a:extLst>
-              <a:ext uri="{FF2B5EF4-FFF2-40B4-BE49-F238E27FC236}">
-                <a16:creationId xmlns:a16="http://schemas.microsoft.com/office/drawing/2014/main" id="{78F16532-CC2B-ACFE-4BD5-649BD5FBCD65}"/>
+          <p:cNvPr id="66" name="Textfeld 65">
+            <a:extLst>
+              <a:ext uri="{FF2B5EF4-FFF2-40B4-BE49-F238E27FC236}">
+                <a16:creationId xmlns:a16="http://schemas.microsoft.com/office/drawing/2014/main" id="{E6606810-81A2-44CF-AD86-E79743D72A7B}"/>
               </a:ext>
             </a:extLst>
           </p:cNvPr>
@@ -6097,8 +6180,8 @@
         </p:nvSpPr>
         <p:spPr>
           <a:xfrm>
-            <a:off x="11176000" y="2567305"/>
-            <a:ext cx="889000" cy="153888"/>
+            <a:off x="11176000" y="2554738"/>
+            <a:ext cx="889000" cy="169277"/>
           </a:xfrm>
           <a:prstGeom prst="rect">
             <a:avLst/>
@@ -6113,7 +6196,7 @@
           <a:p>
             <a:pPr algn="ctr"/>
             <a:r>
-              <a:rPr lang="de-DE" sz="1000">
+              <a:rPr lang="de-DE" sz="1100">
                 <a:solidFill>
                   <a:srgbClr val="222222"/>
                 </a:solidFill>
@@ -6126,10 +6209,10 @@
       </p:sp>
       <p:sp>
         <p:nvSpPr>
-          <p:cNvPr id="65" name="Textfeld 64">
-            <a:extLst>
-              <a:ext uri="{FF2B5EF4-FFF2-40B4-BE49-F238E27FC236}">
-                <a16:creationId xmlns:a16="http://schemas.microsoft.com/office/drawing/2014/main" id="{7501E24F-5AE5-5F9F-E552-892521BDC7EB}"/>
+          <p:cNvPr id="67" name="Textfeld 66">
+            <a:extLst>
+              <a:ext uri="{FF2B5EF4-FFF2-40B4-BE49-F238E27FC236}">
+                <a16:creationId xmlns:a16="http://schemas.microsoft.com/office/drawing/2014/main" id="{6F6287BA-B591-4D61-BC2D-B0EEA3B649C7}"/>
               </a:ext>
             </a:extLst>
           </p:cNvPr>
@@ -6139,7 +6222,7 @@
         <p:spPr>
           <a:xfrm>
             <a:off x="11188700" y="4495800"/>
-            <a:ext cx="863600" cy="184666"/>
+            <a:ext cx="863600" cy="200055"/>
           </a:xfrm>
           <a:prstGeom prst="rect">
             <a:avLst/>
@@ -6154,7 +6237,7 @@
           <a:p>
             <a:pPr algn="ctr"/>
             <a:r>
-              <a:rPr lang="de-DE" sz="1200" b="1">
+              <a:rPr lang="de-DE" sz="1300" b="1">
                 <a:solidFill>
                   <a:srgbClr val="222222"/>
                 </a:solidFill>
@@ -6167,10 +6250,10 @@
       </p:sp>
       <p:sp>
         <p:nvSpPr>
-          <p:cNvPr id="66" name="Textfeld 65">
-            <a:extLst>
-              <a:ext uri="{FF2B5EF4-FFF2-40B4-BE49-F238E27FC236}">
-                <a16:creationId xmlns:a16="http://schemas.microsoft.com/office/drawing/2014/main" id="{359FC0F8-D37D-73A3-3598-6F77D861E6C6}"/>
+          <p:cNvPr id="68" name="Textfeld 67">
+            <a:extLst>
+              <a:ext uri="{FF2B5EF4-FFF2-40B4-BE49-F238E27FC236}">
+                <a16:creationId xmlns:a16="http://schemas.microsoft.com/office/drawing/2014/main" id="{45E8B37A-EE38-4100-A959-BFD7C6C035A1}"/>
               </a:ext>
             </a:extLst>
           </p:cNvPr>
@@ -6180,7 +6263,7 @@
         <p:spPr>
           <a:xfrm rot="16200000">
             <a:off x="5715000" y="2387600"/>
-            <a:ext cx="2032000" cy="200055"/>
+            <a:ext cx="2032000" cy="215444"/>
           </a:xfrm>
           <a:prstGeom prst="rect">
             <a:avLst/>
@@ -6195,7 +6278,7 @@
           <a:p>
             <a:pPr algn="ctr"/>
             <a:r>
-              <a:rPr lang="de-DE" sz="1300">
+              <a:rPr lang="de-DE" sz="1400">
                 <a:solidFill>
                   <a:srgbClr val="222222"/>
                 </a:solidFill>
@@ -6208,10 +6291,10 @@
       </p:sp>
       <p:sp>
         <p:nvSpPr>
-          <p:cNvPr id="67" name="Textfeld 66">
-            <a:extLst>
-              <a:ext uri="{FF2B5EF4-FFF2-40B4-BE49-F238E27FC236}">
-                <a16:creationId xmlns:a16="http://schemas.microsoft.com/office/drawing/2014/main" id="{CB717C47-884D-3918-6E44-F865B7C88942}"/>
+          <p:cNvPr id="69" name="Textfeld 68">
+            <a:extLst>
+              <a:ext uri="{FF2B5EF4-FFF2-40B4-BE49-F238E27FC236}">
+                <a16:creationId xmlns:a16="http://schemas.microsoft.com/office/drawing/2014/main" id="{B7FD5551-BD40-4F08-9BB1-B00CEC3763B4}"/>
               </a:ext>
             </a:extLst>
           </p:cNvPr>
@@ -6221,7 +6304,7 @@
         <p:spPr>
           <a:xfrm>
             <a:off x="8763000" y="5054600"/>
-            <a:ext cx="2222500" cy="200055"/>
+            <a:ext cx="2222500" cy="215444"/>
           </a:xfrm>
           <a:prstGeom prst="rect">
             <a:avLst/>
@@ -6236,7 +6319,7 @@
           <a:p>
             <a:pPr algn="ctr"/>
             <a:r>
-              <a:rPr lang="de-DE" sz="1300">
+              <a:rPr lang="de-DE" sz="1400">
                 <a:solidFill>
                   <a:srgbClr val="222222"/>
                 </a:solidFill>
@@ -6250,7 +6333,7 @@
     </p:spTree>
     <p:extLst>
       <p:ext uri="{BB962C8B-B14F-4D97-AF65-F5344CB8AC3E}">
-        <p14:creationId xmlns:p14="http://schemas.microsoft.com/office/powerpoint/2010/main" val="1919156011"/>
+        <p14:creationId xmlns:p14="http://schemas.microsoft.com/office/powerpoint/2010/main" val="3081354919"/>
       </p:ext>
     </p:extLst>
   </p:cSld>
@@ -6271,39 +6354,39 @@
         <a:sysClr val="window" lastClr="FFFFFF"/>
       </a:lt1>
       <a:dk2>
-        <a:srgbClr val="0E2841"/>
+        <a:srgbClr val="44546A"/>
       </a:dk2>
       <a:lt2>
-        <a:srgbClr val="E8E8E8"/>
+        <a:srgbClr val="E7E6E6"/>
       </a:lt2>
       <a:accent1>
-        <a:srgbClr val="156082"/>
+        <a:srgbClr val="4472C4"/>
       </a:accent1>
       <a:accent2>
-        <a:srgbClr val="E97132"/>
+        <a:srgbClr val="ED7D31"/>
       </a:accent2>
       <a:accent3>
-        <a:srgbClr val="196B24"/>
+        <a:srgbClr val="A5A5A5"/>
       </a:accent3>
       <a:accent4>
-        <a:srgbClr val="0F9ED5"/>
+        <a:srgbClr val="FFC000"/>
       </a:accent4>
       <a:accent5>
-        <a:srgbClr val="A02B93"/>
+        <a:srgbClr val="5B9BD5"/>
       </a:accent5>
       <a:accent6>
-        <a:srgbClr val="4EA72E"/>
+        <a:srgbClr val="70AD47"/>
       </a:accent6>
       <a:hlink>
-        <a:srgbClr val="467886"/>
+        <a:srgbClr val="0563C1"/>
       </a:hlink>
       <a:folHlink>
-        <a:srgbClr val="96607D"/>
+        <a:srgbClr val="954F72"/>
       </a:folHlink>
     </a:clrScheme>
     <a:fontScheme name="Office">
       <a:majorFont>
-        <a:latin typeface="Aptos Display" panose="02110004020202020204"/>
+        <a:latin typeface="Calibri Light" panose="020F0302020204030204"/>
         <a:ea typeface=""/>
         <a:cs typeface=""/>
         <a:font script="Jpan" typeface="游ゴシック Light"/>
@@ -6355,7 +6438,7 @@
         <a:font script="Tfng" typeface="Ebrima"/>
       </a:majorFont>
       <a:minorFont>
-        <a:latin typeface="Aptos" panose="02110004020202020204"/>
+        <a:latin typeface="Calibri" panose="020F0502020204030204"/>
         <a:ea typeface=""/>
         <a:cs typeface=""/>
         <a:font script="Jpan" typeface="游ゴシック"/>
@@ -6466,6 +6549,13 @@
         </a:gradFill>
       </a:fillStyleLst>
       <a:lnStyleLst>
+        <a:ln w="6350" cap="flat" cmpd="sng" algn="ctr">
+          <a:solidFill>
+            <a:schemeClr val="phClr"/>
+          </a:solidFill>
+          <a:prstDash val="solid"/>
+          <a:miter lim="800000"/>
+        </a:ln>
         <a:ln w="12700" cap="flat" cmpd="sng" algn="ctr">
           <a:solidFill>
             <a:schemeClr val="phClr"/>
@@ -6474,13 +6564,6 @@
           <a:miter lim="800000"/>
         </a:ln>
         <a:ln w="19050" cap="flat" cmpd="sng" algn="ctr">
-          <a:solidFill>
-            <a:schemeClr val="phClr"/>
-          </a:solidFill>
-          <a:prstDash val="solid"/>
-          <a:miter lim="800000"/>
-        </a:ln>
-        <a:ln w="25400" cap="flat" cmpd="sng" algn="ctr">
           <a:solidFill>
             <a:schemeClr val="phClr"/>
           </a:solidFill>
@@ -6545,31 +6628,11 @@
       </a:bgFillStyleLst>
     </a:fmtScheme>
   </a:themeElements>
-  <a:objectDefaults>
-    <a:lnDef>
-      <a:spPr/>
-      <a:bodyPr/>
-      <a:lstStyle/>
-      <a:style>
-        <a:lnRef idx="2">
-          <a:schemeClr val="accent1"/>
-        </a:lnRef>
-        <a:fillRef idx="0">
-          <a:schemeClr val="accent1"/>
-        </a:fillRef>
-        <a:effectRef idx="1">
-          <a:schemeClr val="accent1"/>
-        </a:effectRef>
-        <a:fontRef idx="minor">
-          <a:schemeClr val="tx1"/>
-        </a:fontRef>
-      </a:style>
-    </a:lnDef>
-  </a:objectDefaults>
+  <a:objectDefaults/>
   <a:extraClrSchemeLst/>
   <a:extLst>
     <a:ext uri="{05A4C25C-085E-4340-85A3-A5531E510DB2}">
-      <thm15:themeFamily xmlns:thm15="http://schemas.microsoft.com/office/thememl/2012/main" name="Office Theme" id="{2E142A2C-CD16-42D6-873A-C26D2A0506FA}" vid="{1BDDFF52-6CD6-40A5-AB3C-68EB2F1E4D0A}"/>
+      <thm15:themeFamily xmlns:thm15="http://schemas.microsoft.com/office/thememl/2012/main" name="Office Theme" id="{62F939B6-93AF-4DB8-9C6B-D6C7DFDC589F}" vid="{4A3C46E8-61CC-4603-A589-7422A47A8E4A}"/>
     </a:ext>
   </a:extLst>
 </a:theme>

</xml_diff>